<commit_message>
Update JavaIntro slides for genAI and IntelliJ
</commit_message>
<xml_diff>
--- a/ClassMaterials/JavaIntro/Slides/Part2-JavaIntro.pptx
+++ b/ClassMaterials/JavaIntro/Slides/Part2-JavaIntro.pptx
@@ -9,7 +9,7 @@
   </p:notesMasterIdLst>
   <p:sldIdLst>
     <p:sldId id="333" r:id="rId2"/>
-    <p:sldId id="334" r:id="rId3"/>
+    <p:sldId id="350" r:id="rId3"/>
     <p:sldId id="335" r:id="rId4"/>
     <p:sldId id="336" r:id="rId5"/>
     <p:sldId id="337" r:id="rId6"/>
@@ -1101,14 +1101,63 @@
           <a:bodyPr/>
           <a:lstStyle/>
           <a:p>
-            <a:endParaRPr lang="en-US" dirty="0"/>
+            <a:r>
+              <a:rPr lang="en-US" dirty="0"/>
+              <a:t>JAY: I suggest actually writing some code out on the board - things to note:</a:t>
+            </a:r>
+          </a:p>
+          <a:p>
+            <a:pPr marL="342900" indent="-342900">
+              <a:buFont typeface="Arial" panose="020B0604020202020204" pitchFamily="34" charset="0"/>
+              <a:buChar char="•"/>
+            </a:pPr>
+            <a:r>
+              <a:rPr lang="en-US" dirty="0"/>
+              <a:t>{ } enclose code in blocks – Eclipse highlights them for you</a:t>
+            </a:r>
+          </a:p>
+          <a:p>
+            <a:pPr marL="342900" indent="-342900">
+              <a:buFont typeface="Arial" panose="020B0604020202020204" pitchFamily="34" charset="0"/>
+              <a:buChar char="•"/>
+            </a:pPr>
+            <a:r>
+              <a:rPr lang="en-US" dirty="0"/>
+              <a:t>Special words have different colors</a:t>
+            </a:r>
+          </a:p>
+          <a:p>
+            <a:pPr marL="342900" indent="-342900">
+              <a:buFont typeface="Arial" panose="020B0604020202020204" pitchFamily="34" charset="0"/>
+              <a:buChar char="•"/>
+            </a:pPr>
+            <a:r>
+              <a:rPr lang="en-US" dirty="0"/>
+              <a:t>Semicolons are required</a:t>
+            </a:r>
+          </a:p>
+          <a:p>
+            <a:pPr marL="342900" indent="-342900">
+              <a:buFont typeface="Arial" panose="020B0604020202020204" pitchFamily="34" charset="0"/>
+              <a:buChar char="•"/>
+            </a:pPr>
+            <a:r>
+              <a:rPr lang="en-US" dirty="0"/>
+              <a:t>Capitalization matters and is important</a:t>
+            </a:r>
+          </a:p>
+          <a:p>
+            <a:r>
+              <a:rPr lang="en-US" dirty="0"/>
+              <a:t> </a:t>
+            </a:r>
           </a:p>
         </p:txBody>
       </p:sp>
     </p:spTree>
     <p:extLst>
       <p:ext uri="{BB962C8B-B14F-4D97-AF65-F5344CB8AC3E}">
-        <p14:creationId xmlns:p14="http://schemas.microsoft.com/office/powerpoint/2010/main" val="1235572611"/>
+        <p14:creationId xmlns:p14="http://schemas.microsoft.com/office/powerpoint/2010/main" val="2411726575"/>
       </p:ext>
     </p:extLst>
   </p:cSld>
@@ -1119,6 +1168,238 @@
 </file>
 
 <file path=ppt/notesSlides/notesSlide3.xml><?xml version="1.0" encoding="utf-8"?>
+<p:notes xmlns:a="http://schemas.openxmlformats.org/drawingml/2006/main" xmlns:r="http://schemas.openxmlformats.org/officeDocument/2006/relationships" xmlns:p="http://schemas.openxmlformats.org/presentationml/2006/main">
+  <p:cSld>
+    <p:spTree>
+      <p:nvGrpSpPr>
+        <p:cNvPr id="1" name=""/>
+        <p:cNvGrpSpPr/>
+        <p:nvPr/>
+      </p:nvGrpSpPr>
+      <p:grpSpPr>
+        <a:xfrm>
+          <a:off x="0" y="0"/>
+          <a:ext cx="0" cy="0"/>
+          <a:chOff x="0" y="0"/>
+          <a:chExt cx="0" cy="0"/>
+        </a:xfrm>
+      </p:grpSpPr>
+      <p:sp>
+        <p:nvSpPr>
+          <p:cNvPr id="127" name="Shape 127"/>
+          <p:cNvSpPr>
+            <a:spLocks noGrp="1" noRot="1" noChangeAspect="1"/>
+          </p:cNvSpPr>
+          <p:nvPr>
+            <p:ph type="sldImg"/>
+          </p:nvPr>
+        </p:nvSpPr>
+        <p:spPr>
+          <a:prstGeom prst="rect">
+            <a:avLst/>
+          </a:prstGeom>
+        </p:spPr>
+        <p:txBody>
+          <a:bodyPr/>
+          <a:lstStyle/>
+          <a:p>
+            <a:pPr lvl="0"/>
+            <a:endParaRPr/>
+          </a:p>
+        </p:txBody>
+      </p:sp>
+      <p:sp>
+        <p:nvSpPr>
+          <p:cNvPr id="128" name="Shape 128"/>
+          <p:cNvSpPr>
+            <a:spLocks noGrp="1"/>
+          </p:cNvSpPr>
+          <p:nvPr>
+            <p:ph type="body" sz="quarter" idx="1"/>
+          </p:nvPr>
+        </p:nvSpPr>
+        <p:spPr>
+          <a:prstGeom prst="rect">
+            <a:avLst/>
+          </a:prstGeom>
+        </p:spPr>
+        <p:txBody>
+          <a:bodyPr/>
+          <a:lstStyle/>
+          <a:p>
+            <a:pPr lvl="0" defTabSz="914400">
+              <a:lnSpc>
+                <a:spcPct val="100000"/>
+              </a:lnSpc>
+              <a:defRPr sz="1800"/>
+            </a:pPr>
+            <a:r>
+              <a:rPr sz="1200" b="1">
+                <a:latin typeface="Lucida Sans"/>
+                <a:ea typeface="Lucida Sans"/>
+                <a:cs typeface="Lucida Sans"/>
+                <a:sym typeface="Lucida Sans"/>
+              </a:rPr>
+              <a:t>Argument for main </a:t>
+            </a:r>
+            <a:r>
+              <a:rPr sz="1200">
+                <a:latin typeface="Lucida Sans"/>
+                <a:ea typeface="Lucida Sans"/>
+                <a:cs typeface="Lucida Sans"/>
+                <a:sym typeface="Lucida Sans"/>
+              </a:rPr>
+              <a:t>is not optional.  Must be there.</a:t>
+            </a:r>
+            <a:endParaRPr sz="1200">
+              <a:latin typeface="Gill Sans"/>
+              <a:ea typeface="Gill Sans"/>
+              <a:cs typeface="Gill Sans"/>
+              <a:sym typeface="Gill Sans"/>
+            </a:endParaRPr>
+          </a:p>
+          <a:p>
+            <a:pPr lvl="0" defTabSz="914400">
+              <a:lnSpc>
+                <a:spcPct val="100000"/>
+              </a:lnSpc>
+              <a:defRPr sz="1800"/>
+            </a:pPr>
+            <a:endParaRPr sz="1200">
+              <a:latin typeface="Lucida Sans"/>
+              <a:ea typeface="Lucida Sans"/>
+              <a:cs typeface="Lucida Sans"/>
+              <a:sym typeface="Lucida Sans"/>
+            </a:endParaRPr>
+          </a:p>
+          <a:p>
+            <a:pPr lvl="0" defTabSz="914400">
+              <a:lnSpc>
+                <a:spcPct val="100000"/>
+              </a:lnSpc>
+              <a:defRPr sz="1800"/>
+            </a:pPr>
+            <a:endParaRPr sz="1200">
+              <a:latin typeface="Lucida Sans"/>
+              <a:ea typeface="Lucida Sans"/>
+              <a:cs typeface="Lucida Sans"/>
+              <a:sym typeface="Lucida Sans"/>
+            </a:endParaRPr>
+          </a:p>
+        </p:txBody>
+      </p:sp>
+    </p:spTree>
+    <p:extLst>
+      <p:ext uri="{BB962C8B-B14F-4D97-AF65-F5344CB8AC3E}">
+        <p14:creationId xmlns:p14="http://schemas.microsoft.com/office/powerpoint/2010/main" val="2682829326"/>
+      </p:ext>
+    </p:extLst>
+  </p:cSld>
+  <p:clrMapOvr>
+    <a:masterClrMapping/>
+  </p:clrMapOvr>
+</p:notes>
+</file>
+
+<file path=ppt/notesSlides/notesSlide4.xml><?xml version="1.0" encoding="utf-8"?>
+<p:notes xmlns:a="http://schemas.openxmlformats.org/drawingml/2006/main" xmlns:r="http://schemas.openxmlformats.org/officeDocument/2006/relationships" xmlns:p="http://schemas.openxmlformats.org/presentationml/2006/main">
+  <p:cSld>
+    <p:spTree>
+      <p:nvGrpSpPr>
+        <p:cNvPr id="1" name=""/>
+        <p:cNvGrpSpPr/>
+        <p:nvPr/>
+      </p:nvGrpSpPr>
+      <p:grpSpPr>
+        <a:xfrm>
+          <a:off x="0" y="0"/>
+          <a:ext cx="0" cy="0"/>
+          <a:chOff x="0" y="0"/>
+          <a:chExt cx="0" cy="0"/>
+        </a:xfrm>
+      </p:grpSpPr>
+      <p:sp>
+        <p:nvSpPr>
+          <p:cNvPr id="99" name="Shape 99"/>
+          <p:cNvSpPr>
+            <a:spLocks noGrp="1" noRot="1" noChangeAspect="1"/>
+          </p:cNvSpPr>
+          <p:nvPr>
+            <p:ph type="sldImg"/>
+          </p:nvPr>
+        </p:nvSpPr>
+        <p:spPr>
+          <a:prstGeom prst="rect">
+            <a:avLst/>
+          </a:prstGeom>
+        </p:spPr>
+        <p:txBody>
+          <a:bodyPr/>
+          <a:lstStyle/>
+          <a:p>
+            <a:pPr lvl="0"/>
+            <a:endParaRPr/>
+          </a:p>
+        </p:txBody>
+      </p:sp>
+      <p:sp>
+        <p:nvSpPr>
+          <p:cNvPr id="100" name="Shape 100"/>
+          <p:cNvSpPr>
+            <a:spLocks noGrp="1"/>
+          </p:cNvSpPr>
+          <p:nvPr>
+            <p:ph type="body" sz="quarter" idx="1"/>
+          </p:nvPr>
+        </p:nvSpPr>
+        <p:spPr>
+          <a:prstGeom prst="rect">
+            <a:avLst/>
+          </a:prstGeom>
+        </p:spPr>
+        <p:txBody>
+          <a:bodyPr/>
+          <a:lstStyle>
+            <a:lvl1pPr defTabSz="914400">
+              <a:lnSpc>
+                <a:spcPct val="100000"/>
+              </a:lnSpc>
+              <a:spcBef>
+                <a:spcPts val="400"/>
+              </a:spcBef>
+              <a:defRPr sz="1200">
+                <a:latin typeface="Lucida Sans"/>
+                <a:ea typeface="Lucida Sans"/>
+                <a:cs typeface="Lucida Sans"/>
+                <a:sym typeface="Lucida Sans"/>
+              </a:defRPr>
+            </a:lvl1pPr>
+          </a:lstStyle>
+          <a:p>
+            <a:pPr lvl="0">
+              <a:defRPr sz="1800"/>
+            </a:pPr>
+            <a:r>
+              <a:rPr sz="1200"/>
+              <a:t>Discuss errors and error messages</a:t>
+            </a:r>
+          </a:p>
+        </p:txBody>
+      </p:sp>
+    </p:spTree>
+    <p:extLst>
+      <p:ext uri="{BB962C8B-B14F-4D97-AF65-F5344CB8AC3E}">
+        <p14:creationId xmlns:p14="http://schemas.microsoft.com/office/powerpoint/2010/main" val="942886938"/>
+      </p:ext>
+    </p:extLst>
+  </p:cSld>
+  <p:clrMapOvr>
+    <a:masterClrMapping/>
+  </p:clrMapOvr>
+</p:notes>
+</file>
+
+<file path=ppt/notesSlides/notesSlide5.xml><?xml version="1.0" encoding="utf-8"?>
 <p:notes xmlns:a="http://schemas.openxmlformats.org/drawingml/2006/main" xmlns:r="http://schemas.openxmlformats.org/officeDocument/2006/relationships" xmlns:p="http://schemas.openxmlformats.org/presentationml/2006/main">
   <p:cSld>
     <p:spTree>
@@ -1162,295 +1443,14 @@
           <a:bodyPr/>
           <a:lstStyle/>
           <a:p>
-            <a:r>
-              <a:rPr lang="en-US" dirty="0"/>
-              <a:t>JAY: I suggest actually writing some code out on the board - things to note:</a:t>
-            </a:r>
-          </a:p>
-          <a:p>
-            <a:pPr marL="342900" indent="-342900">
-              <a:buFont typeface="Arial" panose="020B0604020202020204" pitchFamily="34" charset="0"/>
-              <a:buChar char="•"/>
-            </a:pPr>
-            <a:r>
-              <a:rPr lang="en-US" dirty="0"/>
-              <a:t>{ } enclose code in blocks – Eclipse highlights them for you</a:t>
-            </a:r>
-          </a:p>
-          <a:p>
-            <a:pPr marL="342900" indent="-342900">
-              <a:buFont typeface="Arial" panose="020B0604020202020204" pitchFamily="34" charset="0"/>
-              <a:buChar char="•"/>
-            </a:pPr>
-            <a:r>
-              <a:rPr lang="en-US" dirty="0"/>
-              <a:t>Special words have different colors</a:t>
-            </a:r>
-          </a:p>
-          <a:p>
-            <a:pPr marL="342900" indent="-342900">
-              <a:buFont typeface="Arial" panose="020B0604020202020204" pitchFamily="34" charset="0"/>
-              <a:buChar char="•"/>
-            </a:pPr>
-            <a:r>
-              <a:rPr lang="en-US" dirty="0"/>
-              <a:t>Semicolons are required</a:t>
-            </a:r>
-          </a:p>
-          <a:p>
-            <a:pPr marL="342900" indent="-342900">
-              <a:buFont typeface="Arial" panose="020B0604020202020204" pitchFamily="34" charset="0"/>
-              <a:buChar char="•"/>
-            </a:pPr>
-            <a:r>
-              <a:rPr lang="en-US" dirty="0"/>
-              <a:t>Capitalization matters and is important</a:t>
-            </a:r>
-          </a:p>
-          <a:p>
-            <a:r>
-              <a:rPr lang="en-US" dirty="0"/>
-              <a:t> </a:t>
-            </a:r>
+            <a:endParaRPr lang="en-US" dirty="0"/>
           </a:p>
         </p:txBody>
       </p:sp>
     </p:spTree>
     <p:extLst>
       <p:ext uri="{BB962C8B-B14F-4D97-AF65-F5344CB8AC3E}">
-        <p14:creationId xmlns:p14="http://schemas.microsoft.com/office/powerpoint/2010/main" val="2411726575"/>
-      </p:ext>
-    </p:extLst>
-  </p:cSld>
-  <p:clrMapOvr>
-    <a:masterClrMapping/>
-  </p:clrMapOvr>
-</p:notes>
-</file>
-
-<file path=ppt/notesSlides/notesSlide4.xml><?xml version="1.0" encoding="utf-8"?>
-<p:notes xmlns:a="http://schemas.openxmlformats.org/drawingml/2006/main" xmlns:r="http://schemas.openxmlformats.org/officeDocument/2006/relationships" xmlns:p="http://schemas.openxmlformats.org/presentationml/2006/main">
-  <p:cSld>
-    <p:spTree>
-      <p:nvGrpSpPr>
-        <p:cNvPr id="1" name=""/>
-        <p:cNvGrpSpPr/>
-        <p:nvPr/>
-      </p:nvGrpSpPr>
-      <p:grpSpPr>
-        <a:xfrm>
-          <a:off x="0" y="0"/>
-          <a:ext cx="0" cy="0"/>
-          <a:chOff x="0" y="0"/>
-          <a:chExt cx="0" cy="0"/>
-        </a:xfrm>
-      </p:grpSpPr>
-      <p:sp>
-        <p:nvSpPr>
-          <p:cNvPr id="127" name="Shape 127"/>
-          <p:cNvSpPr>
-            <a:spLocks noGrp="1" noRot="1" noChangeAspect="1"/>
-          </p:cNvSpPr>
-          <p:nvPr>
-            <p:ph type="sldImg"/>
-          </p:nvPr>
-        </p:nvSpPr>
-        <p:spPr>
-          <a:prstGeom prst="rect">
-            <a:avLst/>
-          </a:prstGeom>
-        </p:spPr>
-        <p:txBody>
-          <a:bodyPr/>
-          <a:lstStyle/>
-          <a:p>
-            <a:pPr lvl="0"/>
-            <a:endParaRPr/>
-          </a:p>
-        </p:txBody>
-      </p:sp>
-      <p:sp>
-        <p:nvSpPr>
-          <p:cNvPr id="128" name="Shape 128"/>
-          <p:cNvSpPr>
-            <a:spLocks noGrp="1"/>
-          </p:cNvSpPr>
-          <p:nvPr>
-            <p:ph type="body" sz="quarter" idx="1"/>
-          </p:nvPr>
-        </p:nvSpPr>
-        <p:spPr>
-          <a:prstGeom prst="rect">
-            <a:avLst/>
-          </a:prstGeom>
-        </p:spPr>
-        <p:txBody>
-          <a:bodyPr/>
-          <a:lstStyle/>
-          <a:p>
-            <a:pPr lvl="0" defTabSz="914400">
-              <a:lnSpc>
-                <a:spcPct val="100000"/>
-              </a:lnSpc>
-              <a:defRPr sz="1800"/>
-            </a:pPr>
-            <a:r>
-              <a:rPr sz="1200" b="1">
-                <a:latin typeface="Lucida Sans"/>
-                <a:ea typeface="Lucida Sans"/>
-                <a:cs typeface="Lucida Sans"/>
-                <a:sym typeface="Lucida Sans"/>
-              </a:rPr>
-              <a:t>Argument for main </a:t>
-            </a:r>
-            <a:r>
-              <a:rPr sz="1200">
-                <a:latin typeface="Lucida Sans"/>
-                <a:ea typeface="Lucida Sans"/>
-                <a:cs typeface="Lucida Sans"/>
-                <a:sym typeface="Lucida Sans"/>
-              </a:rPr>
-              <a:t>is not optional.  Must be there.</a:t>
-            </a:r>
-            <a:endParaRPr sz="1200">
-              <a:latin typeface="Gill Sans"/>
-              <a:ea typeface="Gill Sans"/>
-              <a:cs typeface="Gill Sans"/>
-              <a:sym typeface="Gill Sans"/>
-            </a:endParaRPr>
-          </a:p>
-          <a:p>
-            <a:pPr lvl="0" defTabSz="914400">
-              <a:lnSpc>
-                <a:spcPct val="100000"/>
-              </a:lnSpc>
-              <a:defRPr sz="1800"/>
-            </a:pPr>
-            <a:endParaRPr sz="1200">
-              <a:latin typeface="Lucida Sans"/>
-              <a:ea typeface="Lucida Sans"/>
-              <a:cs typeface="Lucida Sans"/>
-              <a:sym typeface="Lucida Sans"/>
-            </a:endParaRPr>
-          </a:p>
-          <a:p>
-            <a:pPr lvl="0" defTabSz="914400">
-              <a:lnSpc>
-                <a:spcPct val="100000"/>
-              </a:lnSpc>
-              <a:defRPr sz="1800"/>
-            </a:pPr>
-            <a:endParaRPr sz="1200">
-              <a:latin typeface="Lucida Sans"/>
-              <a:ea typeface="Lucida Sans"/>
-              <a:cs typeface="Lucida Sans"/>
-              <a:sym typeface="Lucida Sans"/>
-            </a:endParaRPr>
-          </a:p>
-        </p:txBody>
-      </p:sp>
-    </p:spTree>
-    <p:extLst>
-      <p:ext uri="{BB962C8B-B14F-4D97-AF65-F5344CB8AC3E}">
-        <p14:creationId xmlns:p14="http://schemas.microsoft.com/office/powerpoint/2010/main" val="2682829326"/>
-      </p:ext>
-    </p:extLst>
-  </p:cSld>
-  <p:clrMapOvr>
-    <a:masterClrMapping/>
-  </p:clrMapOvr>
-</p:notes>
-</file>
-
-<file path=ppt/notesSlides/notesSlide5.xml><?xml version="1.0" encoding="utf-8"?>
-<p:notes xmlns:a="http://schemas.openxmlformats.org/drawingml/2006/main" xmlns:r="http://schemas.openxmlformats.org/officeDocument/2006/relationships" xmlns:p="http://schemas.openxmlformats.org/presentationml/2006/main">
-  <p:cSld>
-    <p:spTree>
-      <p:nvGrpSpPr>
-        <p:cNvPr id="1" name=""/>
-        <p:cNvGrpSpPr/>
-        <p:nvPr/>
-      </p:nvGrpSpPr>
-      <p:grpSpPr>
-        <a:xfrm>
-          <a:off x="0" y="0"/>
-          <a:ext cx="0" cy="0"/>
-          <a:chOff x="0" y="0"/>
-          <a:chExt cx="0" cy="0"/>
-        </a:xfrm>
-      </p:grpSpPr>
-      <p:sp>
-        <p:nvSpPr>
-          <p:cNvPr id="99" name="Shape 99"/>
-          <p:cNvSpPr>
-            <a:spLocks noGrp="1" noRot="1" noChangeAspect="1"/>
-          </p:cNvSpPr>
-          <p:nvPr>
-            <p:ph type="sldImg"/>
-          </p:nvPr>
-        </p:nvSpPr>
-        <p:spPr>
-          <a:prstGeom prst="rect">
-            <a:avLst/>
-          </a:prstGeom>
-        </p:spPr>
-        <p:txBody>
-          <a:bodyPr/>
-          <a:lstStyle/>
-          <a:p>
-            <a:pPr lvl="0"/>
-            <a:endParaRPr/>
-          </a:p>
-        </p:txBody>
-      </p:sp>
-      <p:sp>
-        <p:nvSpPr>
-          <p:cNvPr id="100" name="Shape 100"/>
-          <p:cNvSpPr>
-            <a:spLocks noGrp="1"/>
-          </p:cNvSpPr>
-          <p:nvPr>
-            <p:ph type="body" sz="quarter" idx="1"/>
-          </p:nvPr>
-        </p:nvSpPr>
-        <p:spPr>
-          <a:prstGeom prst="rect">
-            <a:avLst/>
-          </a:prstGeom>
-        </p:spPr>
-        <p:txBody>
-          <a:bodyPr/>
-          <a:lstStyle>
-            <a:lvl1pPr defTabSz="914400">
-              <a:lnSpc>
-                <a:spcPct val="100000"/>
-              </a:lnSpc>
-              <a:spcBef>
-                <a:spcPts val="400"/>
-              </a:spcBef>
-              <a:defRPr sz="1200">
-                <a:latin typeface="Lucida Sans"/>
-                <a:ea typeface="Lucida Sans"/>
-                <a:cs typeface="Lucida Sans"/>
-                <a:sym typeface="Lucida Sans"/>
-              </a:defRPr>
-            </a:lvl1pPr>
-          </a:lstStyle>
-          <a:p>
-            <a:pPr lvl="0">
-              <a:defRPr sz="1800"/>
-            </a:pPr>
-            <a:r>
-              <a:rPr sz="1200"/>
-              <a:t>Discuss errors and error messages</a:t>
-            </a:r>
-          </a:p>
-        </p:txBody>
-      </p:sp>
-    </p:spTree>
-    <p:extLst>
-      <p:ext uri="{BB962C8B-B14F-4D97-AF65-F5344CB8AC3E}">
-        <p14:creationId xmlns:p14="http://schemas.microsoft.com/office/powerpoint/2010/main" val="942886938"/>
+        <p14:creationId xmlns:p14="http://schemas.microsoft.com/office/powerpoint/2010/main" val="5505768"/>
       </p:ext>
     </p:extLst>
   </p:cSld>
@@ -1511,7 +1511,7 @@
     </p:spTree>
     <p:extLst>
       <p:ext uri="{BB962C8B-B14F-4D97-AF65-F5344CB8AC3E}">
-        <p14:creationId xmlns:p14="http://schemas.microsoft.com/office/powerpoint/2010/main" val="5505768"/>
+        <p14:creationId xmlns:p14="http://schemas.microsoft.com/office/powerpoint/2010/main" val="66220340"/>
       </p:ext>
     </p:extLst>
   </p:cSld>
@@ -1522,67 +1522,6 @@
 </file>
 
 <file path=ppt/notesSlides/notesSlide7.xml><?xml version="1.0" encoding="utf-8"?>
-<p:notes xmlns:a="http://schemas.openxmlformats.org/drawingml/2006/main" xmlns:r="http://schemas.openxmlformats.org/officeDocument/2006/relationships" xmlns:p="http://schemas.openxmlformats.org/presentationml/2006/main">
-  <p:cSld>
-    <p:spTree>
-      <p:nvGrpSpPr>
-        <p:cNvPr id="1" name=""/>
-        <p:cNvGrpSpPr/>
-        <p:nvPr/>
-      </p:nvGrpSpPr>
-      <p:grpSpPr>
-        <a:xfrm>
-          <a:off x="0" y="0"/>
-          <a:ext cx="0" cy="0"/>
-          <a:chOff x="0" y="0"/>
-          <a:chExt cx="0" cy="0"/>
-        </a:xfrm>
-      </p:grpSpPr>
-      <p:sp>
-        <p:nvSpPr>
-          <p:cNvPr id="2" name="Slide Image Placeholder 1"/>
-          <p:cNvSpPr>
-            <a:spLocks noGrp="1" noRot="1" noChangeAspect="1"/>
-          </p:cNvSpPr>
-          <p:nvPr>
-            <p:ph type="sldImg"/>
-          </p:nvPr>
-        </p:nvSpPr>
-        <p:spPr/>
-      </p:sp>
-      <p:sp>
-        <p:nvSpPr>
-          <p:cNvPr id="3" name="Notes Placeholder 2"/>
-          <p:cNvSpPr>
-            <a:spLocks noGrp="1"/>
-          </p:cNvSpPr>
-          <p:nvPr>
-            <p:ph type="body" idx="1"/>
-          </p:nvPr>
-        </p:nvSpPr>
-        <p:spPr/>
-        <p:txBody>
-          <a:bodyPr/>
-          <a:lstStyle/>
-          <a:p>
-            <a:endParaRPr lang="en-US" dirty="0"/>
-          </a:p>
-        </p:txBody>
-      </p:sp>
-    </p:spTree>
-    <p:extLst>
-      <p:ext uri="{BB962C8B-B14F-4D97-AF65-F5344CB8AC3E}">
-        <p14:creationId xmlns:p14="http://schemas.microsoft.com/office/powerpoint/2010/main" val="66220340"/>
-      </p:ext>
-    </p:extLst>
-  </p:cSld>
-  <p:clrMapOvr>
-    <a:masterClrMapping/>
-  </p:clrMapOvr>
-</p:notes>
-</file>
-
-<file path=ppt/notesSlides/notesSlide8.xml><?xml version="1.0" encoding="utf-8"?>
 <p:notes xmlns:a="http://schemas.openxmlformats.org/drawingml/2006/main" xmlns:r="http://schemas.openxmlformats.org/officeDocument/2006/relationships" xmlns:p="http://schemas.openxmlformats.org/presentationml/2006/main">
   <p:cSld>
     <p:spTree>
@@ -1671,67 +1610,6 @@
     <p:extLst>
       <p:ext uri="{BB962C8B-B14F-4D97-AF65-F5344CB8AC3E}">
         <p14:creationId xmlns:p14="http://schemas.microsoft.com/office/powerpoint/2010/main" val="3746845533"/>
-      </p:ext>
-    </p:extLst>
-  </p:cSld>
-  <p:clrMapOvr>
-    <a:masterClrMapping/>
-  </p:clrMapOvr>
-</p:notes>
-</file>
-
-<file path=ppt/notesSlides/notesSlide9.xml><?xml version="1.0" encoding="utf-8"?>
-<p:notes xmlns:a="http://schemas.openxmlformats.org/drawingml/2006/main" xmlns:r="http://schemas.openxmlformats.org/officeDocument/2006/relationships" xmlns:p="http://schemas.openxmlformats.org/presentationml/2006/main">
-  <p:cSld>
-    <p:spTree>
-      <p:nvGrpSpPr>
-        <p:cNvPr id="1" name=""/>
-        <p:cNvGrpSpPr/>
-        <p:nvPr/>
-      </p:nvGrpSpPr>
-      <p:grpSpPr>
-        <a:xfrm>
-          <a:off x="0" y="0"/>
-          <a:ext cx="0" cy="0"/>
-          <a:chOff x="0" y="0"/>
-          <a:chExt cx="0" cy="0"/>
-        </a:xfrm>
-      </p:grpSpPr>
-      <p:sp>
-        <p:nvSpPr>
-          <p:cNvPr id="2" name="Slide Image Placeholder 1"/>
-          <p:cNvSpPr>
-            <a:spLocks noGrp="1" noRot="1" noChangeAspect="1"/>
-          </p:cNvSpPr>
-          <p:nvPr>
-            <p:ph type="sldImg"/>
-          </p:nvPr>
-        </p:nvSpPr>
-        <p:spPr/>
-      </p:sp>
-      <p:sp>
-        <p:nvSpPr>
-          <p:cNvPr id="3" name="Notes Placeholder 2"/>
-          <p:cNvSpPr>
-            <a:spLocks noGrp="1"/>
-          </p:cNvSpPr>
-          <p:nvPr>
-            <p:ph type="body" idx="1"/>
-          </p:nvPr>
-        </p:nvSpPr>
-        <p:spPr/>
-        <p:txBody>
-          <a:bodyPr/>
-          <a:lstStyle/>
-          <a:p>
-            <a:endParaRPr lang="en-US" dirty="0"/>
-          </a:p>
-        </p:txBody>
-      </p:sp>
-    </p:spTree>
-    <p:extLst>
-      <p:ext uri="{BB962C8B-B14F-4D97-AF65-F5344CB8AC3E}">
-        <p14:creationId xmlns:p14="http://schemas.microsoft.com/office/powerpoint/2010/main" val="2757075583"/>
       </p:ext>
     </p:extLst>
   </p:cSld>
@@ -3455,7 +3333,7 @@
           <a:p>
             <a:r>
               <a:rPr lang="en-US" dirty="0"/>
-              <a:t>You have 2 homework assignments in the very near future</a:t>
+              <a:t>You have two homework assignments due in the very near future</a:t>
             </a:r>
           </a:p>
           <a:p>
@@ -3465,7 +3343,7 @@
             </a:r>
             <a:r>
               <a:rPr lang="en-US" dirty="0" err="1"/>
-              <a:t>FirstDayQuiz</a:t>
+              <a:t>JavaIntroQuiz</a:t>
             </a:r>
             <a:r>
               <a:rPr lang="en-US" dirty="0"/>
@@ -3475,16 +3353,13 @@
           <a:p>
             <a:r>
               <a:rPr lang="en-US" dirty="0"/>
-              <a:t>To see all assignment due dates, look at the </a:t>
+              <a:t>To see all assignment due dates, look at the calendar on Moodle, or </a:t>
             </a:r>
             <a:r>
               <a:rPr lang="en-US" dirty="0" err="1"/>
-              <a:t>Airtable</a:t>
-            </a:r>
-            <a:r>
-              <a:rPr lang="en-US" dirty="0"/>
-              <a:t> view on Moodle (next slide)</a:t>
-            </a:r>
+              <a:t>Gradescope</a:t>
+            </a:r>
+            <a:endParaRPr lang="en-US" dirty="0"/>
           </a:p>
           <a:p>
             <a:r>
@@ -4003,19 +3878,8 @@
           <a:p>
             <a:r>
               <a:rPr lang="en-US" dirty="0"/>
-              <a:t>There's instructions in the Homework section of the course Moodle (linked in </a:t>
-            </a:r>
-            <a:r>
-              <a:rPr lang="en-US" dirty="0" err="1"/>
-              <a:t>Airtable</a:t>
-            </a:r>
-            <a:r>
-              <a:rPr lang="en-US" dirty="0"/>
-              <a:t> too)</a:t>
-            </a:r>
-          </a:p>
-          <a:p>
-            <a:endParaRPr lang="en-US" dirty="0"/>
+              <a:t>There's instructions in the Homework section of the course Moodle</a:t>
+            </a:r>
           </a:p>
           <a:p>
             <a:pPr marL="0" indent="0">
@@ -4086,41 +3950,6 @@
           <a:xfrm>
             <a:off x="5334000" y="3657600"/>
             <a:ext cx="3486150" cy="2933700"/>
-          </a:xfrm>
-          <a:prstGeom prst="rect">
-            <a:avLst/>
-          </a:prstGeom>
-          <a:ln>
-            <a:solidFill>
-              <a:schemeClr val="tx1"/>
-            </a:solidFill>
-          </a:ln>
-        </p:spPr>
-      </p:pic>
-      <p:pic>
-        <p:nvPicPr>
-          <p:cNvPr id="5" name="Picture 4">
-            <a:extLst>
-              <a:ext uri="{FF2B5EF4-FFF2-40B4-BE49-F238E27FC236}">
-                <a16:creationId xmlns:a16="http://schemas.microsoft.com/office/drawing/2014/main" id="{BDDDBF1A-61FB-62C8-6EB5-CE002E73FA4E}"/>
-              </a:ext>
-            </a:extLst>
-          </p:cNvPr>
-          <p:cNvPicPr>
-            <a:picLocks noChangeAspect="1"/>
-          </p:cNvPicPr>
-          <p:nvPr/>
-        </p:nvPicPr>
-        <p:blipFill>
-          <a:blip r:embed="rId3"/>
-          <a:stretch>
-            <a:fillRect/>
-          </a:stretch>
-        </p:blipFill>
-        <p:spPr>
-          <a:xfrm>
-            <a:off x="457200" y="3200400"/>
-            <a:ext cx="4600575" cy="2333625"/>
           </a:xfrm>
           <a:prstGeom prst="rect">
             <a:avLst/>
@@ -4593,7 +4422,7 @@
             </a:pPr>
             <a:r>
               <a:rPr lang="en-US" sz="4725" b="1" dirty="0"/>
-              <a:t>HW1 due soon, </a:t>
+              <a:t>HW0 due soon, </a:t>
             </a:r>
             <a:br>
               <a:rPr sz="4725" b="1" dirty="0"/>
@@ -4614,7 +4443,7 @@
             </a:br>
             <a:r>
               <a:rPr lang="en-US" sz="4725" b="1" dirty="0" err="1"/>
-              <a:t>FirstDayQuiz</a:t>
+              <a:t>JavaIntroQuiz</a:t>
             </a:r>
             <a:r>
               <a:rPr lang="en-US" sz="4725" b="1" dirty="0"/>
@@ -4638,19 +4467,9 @@
             </a:br>
             <a:r>
               <a:rPr lang="en-US" sz="4725" b="1" dirty="0"/>
-              <a:t>Post on Piazza or </a:t>
-            </a:r>
-            <a:r>
-              <a:rPr sz="4725" b="1" dirty="0"/>
-              <a:t>email me </a:t>
-            </a:r>
-            <a:br>
-              <a:rPr lang="en-US" sz="4725" b="1" dirty="0"/>
-            </a:br>
-            <a:r>
-              <a:rPr sz="4725" b="1" dirty="0"/>
-              <a:t>if you have any questions</a:t>
-            </a:r>
+              <a:t>Reach out if you have any questions</a:t>
+            </a:r>
+            <a:endParaRPr sz="4725" b="1" dirty="0"/>
           </a:p>
         </p:txBody>
       </p:sp>
@@ -4715,6 +4534,140 @@
   <p:cSld>
     <p:spTree>
       <p:nvGrpSpPr>
+        <p:cNvPr id="1" name="">
+          <a:extLst>
+            <a:ext uri="{FF2B5EF4-FFF2-40B4-BE49-F238E27FC236}">
+              <a16:creationId xmlns:a16="http://schemas.microsoft.com/office/drawing/2014/main" id="{F1ECCB2F-C101-85FE-D041-F346D34ECBB6}"/>
+            </a:ext>
+          </a:extLst>
+        </p:cNvPr>
+        <p:cNvGrpSpPr/>
+        <p:nvPr/>
+      </p:nvGrpSpPr>
+      <p:grpSpPr>
+        <a:xfrm>
+          <a:off x="0" y="0"/>
+          <a:ext cx="0" cy="0"/>
+          <a:chOff x="0" y="0"/>
+          <a:chExt cx="0" cy="0"/>
+        </a:xfrm>
+      </p:grpSpPr>
+      <p:sp>
+        <p:nvSpPr>
+          <p:cNvPr id="2" name="Title 1">
+            <a:extLst>
+              <a:ext uri="{FF2B5EF4-FFF2-40B4-BE49-F238E27FC236}">
+                <a16:creationId xmlns:a16="http://schemas.microsoft.com/office/drawing/2014/main" id="{BB8E672A-CF24-E9CD-AE73-934D6EAE83F3}"/>
+              </a:ext>
+            </a:extLst>
+          </p:cNvPr>
+          <p:cNvSpPr>
+            <a:spLocks noGrp="1"/>
+          </p:cNvSpPr>
+          <p:nvPr>
+            <p:ph type="title"/>
+          </p:nvPr>
+        </p:nvSpPr>
+        <p:spPr/>
+        <p:txBody>
+          <a:bodyPr/>
+          <a:lstStyle/>
+          <a:p>
+            <a:r>
+              <a:rPr lang="en-US" dirty="0">
+                <a:latin typeface="Grandview" panose="020B0502040204020203" pitchFamily="34" charset="0"/>
+              </a:rPr>
+              <a:t>HW0 – How to submit</a:t>
+            </a:r>
+          </a:p>
+        </p:txBody>
+      </p:sp>
+      <p:sp>
+        <p:nvSpPr>
+          <p:cNvPr id="3" name="Content Placeholder 2">
+            <a:extLst>
+              <a:ext uri="{FF2B5EF4-FFF2-40B4-BE49-F238E27FC236}">
+                <a16:creationId xmlns:a16="http://schemas.microsoft.com/office/drawing/2014/main" id="{58BFCED5-17D2-EEF5-BF37-903D713A367E}"/>
+              </a:ext>
+            </a:extLst>
+          </p:cNvPr>
+          <p:cNvSpPr>
+            <a:spLocks noGrp="1"/>
+          </p:cNvSpPr>
+          <p:nvPr>
+            <p:ph idx="1"/>
+          </p:nvPr>
+        </p:nvSpPr>
+        <p:spPr/>
+        <p:txBody>
+          <a:bodyPr/>
+          <a:lstStyle/>
+          <a:p>
+            <a:r>
+              <a:rPr lang="en-US" dirty="0">
+                <a:latin typeface="Grandview" panose="020B0502040204020203" pitchFamily="34" charset="0"/>
+              </a:rPr>
+              <a:t>Click HW0 link in Moodle to go to </a:t>
+            </a:r>
+            <a:r>
+              <a:rPr lang="en-US" dirty="0" err="1">
+                <a:latin typeface="Grandview" panose="020B0502040204020203" pitchFamily="34" charset="0"/>
+              </a:rPr>
+              <a:t>Gradescope</a:t>
+            </a:r>
+            <a:endParaRPr lang="en-US" dirty="0">
+              <a:latin typeface="Grandview" panose="020B0502040204020203" pitchFamily="34" charset="0"/>
+            </a:endParaRPr>
+          </a:p>
+          <a:p>
+            <a:r>
+              <a:rPr lang="en-US" dirty="0">
+                <a:latin typeface="Grandview" panose="020B0502040204020203" pitchFamily="34" charset="0"/>
+              </a:rPr>
+              <a:t>Drag and drop HW0.java to submit</a:t>
+            </a:r>
+          </a:p>
+          <a:p>
+            <a:r>
+              <a:rPr lang="en-US" dirty="0">
+                <a:latin typeface="Grandview" panose="020B0502040204020203" pitchFamily="34" charset="0"/>
+              </a:rPr>
+              <a:t>Wait for the </a:t>
+            </a:r>
+            <a:r>
+              <a:rPr lang="en-US" dirty="0" err="1">
+                <a:latin typeface="Grandview" panose="020B0502040204020203" pitchFamily="34" charset="0"/>
+              </a:rPr>
+              <a:t>autograder</a:t>
+            </a:r>
+            <a:r>
+              <a:rPr lang="en-US" dirty="0">
+                <a:latin typeface="Grandview" panose="020B0502040204020203" pitchFamily="34" charset="0"/>
+              </a:rPr>
+              <a:t> to finish running</a:t>
+            </a:r>
+          </a:p>
+        </p:txBody>
+      </p:sp>
+    </p:spTree>
+    <p:extLst>
+      <p:ext uri="{BB962C8B-B14F-4D97-AF65-F5344CB8AC3E}">
+        <p14:creationId xmlns:p14="http://schemas.microsoft.com/office/powerpoint/2010/main" val="674903700"/>
+      </p:ext>
+    </p:extLst>
+  </p:cSld>
+  <p:clrMapOvr>
+    <a:masterClrMapping/>
+  </p:clrMapOvr>
+  <p:transition spd="med"/>
+</p:sld>
+</file>
+
+<file path=ppt/slides/slide2.xml><?xml version="1.0" encoding="utf-8"?>
+<p:sld xmlns:a="http://schemas.openxmlformats.org/drawingml/2006/main" xmlns:r="http://schemas.openxmlformats.org/officeDocument/2006/relationships" xmlns:p="http://schemas.openxmlformats.org/presentationml/2006/main" show="0">
+  <p:cSld>
+    <p:spTree>
+      <p:nvGrpSpPr>
         <p:cNvPr id="1" name=""/>
         <p:cNvGrpSpPr/>
         <p:nvPr/>
@@ -4732,413 +4685,7 @@
           <p:cNvPr id="2" name="Title 1">
             <a:extLst>
               <a:ext uri="{FF2B5EF4-FFF2-40B4-BE49-F238E27FC236}">
-                <a16:creationId xmlns:a16="http://schemas.microsoft.com/office/drawing/2014/main" id="{83D4630F-C598-95D2-A677-264975F7D4DB}"/>
-              </a:ext>
-            </a:extLst>
-          </p:cNvPr>
-          <p:cNvSpPr>
-            <a:spLocks noGrp="1"/>
-          </p:cNvSpPr>
-          <p:nvPr>
-            <p:ph type="title"/>
-          </p:nvPr>
-        </p:nvSpPr>
-        <p:spPr>
-          <a:xfrm>
-            <a:off x="628650" y="323640"/>
-            <a:ext cx="7886700" cy="994172"/>
-          </a:xfrm>
-        </p:spPr>
-        <p:txBody>
-          <a:bodyPr>
-            <a:normAutofit/>
-          </a:bodyPr>
-          <a:lstStyle/>
-          <a:p>
-            <a:r>
-              <a:rPr lang="en-US" dirty="0"/>
-              <a:t>Reminder: Useful Links in </a:t>
-            </a:r>
-            <a:r>
-              <a:rPr lang="en-US" dirty="0" err="1"/>
-              <a:t>Airtable</a:t>
-            </a:r>
-            <a:endParaRPr lang="en-US" dirty="0"/>
-          </a:p>
-        </p:txBody>
-      </p:sp>
-      <p:pic>
-        <p:nvPicPr>
-          <p:cNvPr id="5" name="Content Placeholder 4" descr="A screenshot of a computer&#10;&#10;Description automatically generated">
-            <a:extLst>
-              <a:ext uri="{FF2B5EF4-FFF2-40B4-BE49-F238E27FC236}">
-                <a16:creationId xmlns:a16="http://schemas.microsoft.com/office/drawing/2014/main" id="{3A28BBE1-AC40-F1C0-08B3-09EF337CD7AC}"/>
-              </a:ext>
-            </a:extLst>
-          </p:cNvPr>
-          <p:cNvPicPr>
-            <a:picLocks noGrp="1" noChangeAspect="1"/>
-          </p:cNvPicPr>
-          <p:nvPr>
-            <p:ph idx="1"/>
-          </p:nvPr>
-        </p:nvPicPr>
-        <p:blipFill>
-          <a:blip r:embed="rId3"/>
-          <a:stretch>
-            <a:fillRect/>
-          </a:stretch>
-        </p:blipFill>
-        <p:spPr>
-          <a:xfrm>
-            <a:off x="3513763" y="1507157"/>
-            <a:ext cx="5450046" cy="3384625"/>
-          </a:xfrm>
-        </p:spPr>
-      </p:pic>
-      <p:sp>
-        <p:nvSpPr>
-          <p:cNvPr id="13" name="TextBox 12">
-            <a:extLst>
-              <a:ext uri="{FF2B5EF4-FFF2-40B4-BE49-F238E27FC236}">
-                <a16:creationId xmlns:a16="http://schemas.microsoft.com/office/drawing/2014/main" id="{477AD6E2-555F-45D2-149A-5FE1442798BF}"/>
-              </a:ext>
-            </a:extLst>
-          </p:cNvPr>
-          <p:cNvSpPr txBox="1"/>
-          <p:nvPr/>
-        </p:nvSpPr>
-        <p:spPr>
-          <a:xfrm>
-            <a:off x="68726" y="3626269"/>
-            <a:ext cx="3017520" cy="2800767"/>
-          </a:xfrm>
-          <a:prstGeom prst="rect">
-            <a:avLst/>
-          </a:prstGeom>
-          <a:solidFill>
-            <a:schemeClr val="accent1">
-              <a:lumMod val="20000"/>
-              <a:lumOff val="80000"/>
-            </a:schemeClr>
-          </a:solidFill>
-          <a:ln>
-            <a:solidFill>
-              <a:schemeClr val="tx1"/>
-            </a:solidFill>
-          </a:ln>
-        </p:spPr>
-        <p:txBody>
-          <a:bodyPr wrap="square" rtlCol="0">
-            <a:spAutoFit/>
-          </a:bodyPr>
-          <a:lstStyle/>
-          <a:p>
-            <a:pPr algn="l"/>
-            <a:endParaRPr lang="en-US" sz="1600" dirty="0"/>
-          </a:p>
-          <a:p>
-            <a:pPr algn="l"/>
-            <a:endParaRPr lang="en-US" sz="1600" dirty="0"/>
-          </a:p>
-          <a:p>
-            <a:pPr algn="l"/>
-            <a:endParaRPr lang="en-US" sz="1600" dirty="0"/>
-          </a:p>
-          <a:p>
-            <a:pPr algn="l"/>
-            <a:endParaRPr lang="en-US" sz="1600" dirty="0"/>
-          </a:p>
-          <a:p>
-            <a:pPr algn="l"/>
-            <a:endParaRPr lang="en-US" sz="1600" dirty="0"/>
-          </a:p>
-          <a:p>
-            <a:pPr algn="l"/>
-            <a:endParaRPr lang="en-US" sz="1600" dirty="0"/>
-          </a:p>
-          <a:p>
-            <a:pPr algn="l"/>
-            <a:r>
-              <a:rPr lang="en-US" sz="1600" dirty="0"/>
-              <a:t>Various Topic Summaries for CSSE220 Topics. Useful for checking your understanding, review daily material preparing for exams.</a:t>
-            </a:r>
-          </a:p>
-        </p:txBody>
-      </p:sp>
-      <p:pic>
-        <p:nvPicPr>
-          <p:cNvPr id="14" name="Picture 13">
-            <a:extLst>
-              <a:ext uri="{FF2B5EF4-FFF2-40B4-BE49-F238E27FC236}">
-                <a16:creationId xmlns:a16="http://schemas.microsoft.com/office/drawing/2014/main" id="{11D30C01-D557-EBE6-56F2-F79EC3488938}"/>
-              </a:ext>
-            </a:extLst>
-          </p:cNvPr>
-          <p:cNvPicPr>
-            <a:picLocks noChangeAspect="1"/>
-          </p:cNvPicPr>
-          <p:nvPr/>
-        </p:nvPicPr>
-        <p:blipFill>
-          <a:blip r:embed="rId4"/>
-          <a:stretch>
-            <a:fillRect/>
-          </a:stretch>
-        </p:blipFill>
-        <p:spPr>
-          <a:xfrm>
-            <a:off x="180191" y="3869645"/>
-            <a:ext cx="2693570" cy="1143160"/>
-          </a:xfrm>
-          <a:prstGeom prst="rect">
-            <a:avLst/>
-          </a:prstGeom>
-        </p:spPr>
-      </p:pic>
-      <p:sp>
-        <p:nvSpPr>
-          <p:cNvPr id="15" name="TextBox 14">
-            <a:extLst>
-              <a:ext uri="{FF2B5EF4-FFF2-40B4-BE49-F238E27FC236}">
-                <a16:creationId xmlns:a16="http://schemas.microsoft.com/office/drawing/2014/main" id="{017E3B92-AC47-5027-9A6B-DF9660518F15}"/>
-              </a:ext>
-            </a:extLst>
-          </p:cNvPr>
-          <p:cNvSpPr txBox="1"/>
-          <p:nvPr/>
-        </p:nvSpPr>
-        <p:spPr>
-          <a:xfrm>
-            <a:off x="80302" y="1132478"/>
-            <a:ext cx="3017520" cy="2308324"/>
-          </a:xfrm>
-          <a:prstGeom prst="rect">
-            <a:avLst/>
-          </a:prstGeom>
-          <a:solidFill>
-            <a:schemeClr val="accent1">
-              <a:lumMod val="20000"/>
-              <a:lumOff val="80000"/>
-            </a:schemeClr>
-          </a:solidFill>
-          <a:ln>
-            <a:solidFill>
-              <a:schemeClr val="tx1"/>
-            </a:solidFill>
-          </a:ln>
-        </p:spPr>
-        <p:txBody>
-          <a:bodyPr wrap="square" rtlCol="0">
-            <a:spAutoFit/>
-          </a:bodyPr>
-          <a:lstStyle/>
-          <a:p>
-            <a:pPr algn="l"/>
-            <a:endParaRPr lang="en-US" sz="1800" dirty="0"/>
-          </a:p>
-          <a:p>
-            <a:pPr algn="l"/>
-            <a:endParaRPr lang="en-US" sz="1800" dirty="0"/>
-          </a:p>
-          <a:p>
-            <a:pPr algn="l"/>
-            <a:endParaRPr lang="en-US" sz="1800" dirty="0"/>
-          </a:p>
-          <a:p>
-            <a:pPr algn="l"/>
-            <a:endParaRPr lang="en-US" sz="1800" dirty="0"/>
-          </a:p>
-          <a:p>
-            <a:pPr algn="l"/>
-            <a:r>
-              <a:rPr lang="en-US" sz="1800" dirty="0"/>
-              <a:t>Pre-recorded lectures of content. Useful for reviewing confusing material, when you miss part or all of a class.</a:t>
-            </a:r>
-          </a:p>
-        </p:txBody>
-      </p:sp>
-      <p:pic>
-        <p:nvPicPr>
-          <p:cNvPr id="16" name="Picture 15">
-            <a:extLst>
-              <a:ext uri="{FF2B5EF4-FFF2-40B4-BE49-F238E27FC236}">
-                <a16:creationId xmlns:a16="http://schemas.microsoft.com/office/drawing/2014/main" id="{886DF227-E112-AD76-369A-C7ACC343C905}"/>
-              </a:ext>
-            </a:extLst>
-          </p:cNvPr>
-          <p:cNvPicPr>
-            <a:picLocks noChangeAspect="1"/>
-          </p:cNvPicPr>
-          <p:nvPr/>
-        </p:nvPicPr>
-        <p:blipFill>
-          <a:blip r:embed="rId5"/>
-          <a:stretch>
-            <a:fillRect/>
-          </a:stretch>
-        </p:blipFill>
-        <p:spPr>
-          <a:xfrm>
-            <a:off x="195431" y="1400346"/>
-            <a:ext cx="2805035" cy="726304"/>
-          </a:xfrm>
-          <a:prstGeom prst="rect">
-            <a:avLst/>
-          </a:prstGeom>
-        </p:spPr>
-      </p:pic>
-      <p:sp>
-        <p:nvSpPr>
-          <p:cNvPr id="17" name="TextBox 16">
-            <a:extLst>
-              <a:ext uri="{FF2B5EF4-FFF2-40B4-BE49-F238E27FC236}">
-                <a16:creationId xmlns:a16="http://schemas.microsoft.com/office/drawing/2014/main" id="{EB7CC05C-E84E-59DE-1114-D38B01CE2D3D}"/>
-              </a:ext>
-            </a:extLst>
-          </p:cNvPr>
-          <p:cNvSpPr txBox="1"/>
-          <p:nvPr/>
-        </p:nvSpPr>
-        <p:spPr>
-          <a:xfrm>
-            <a:off x="3508540" y="4865108"/>
-            <a:ext cx="5421783" cy="1323439"/>
-          </a:xfrm>
-          <a:prstGeom prst="rect">
-            <a:avLst/>
-          </a:prstGeom>
-          <a:solidFill>
-            <a:schemeClr val="accent1">
-              <a:lumMod val="20000"/>
-              <a:lumOff val="80000"/>
-            </a:schemeClr>
-          </a:solidFill>
-          <a:ln>
-            <a:solidFill>
-              <a:schemeClr val="tx1"/>
-            </a:solidFill>
-          </a:ln>
-        </p:spPr>
-        <p:txBody>
-          <a:bodyPr wrap="square" rtlCol="0">
-            <a:spAutoFit/>
-          </a:bodyPr>
-          <a:lstStyle/>
-          <a:p>
-            <a:endParaRPr lang="en-US" sz="2000" dirty="0"/>
-          </a:p>
-          <a:p>
-            <a:endParaRPr lang="en-US" sz="2000" dirty="0"/>
-          </a:p>
-          <a:p>
-            <a:endParaRPr lang="en-US" sz="2000" dirty="0"/>
-          </a:p>
-          <a:p>
-            <a:r>
-              <a:rPr lang="en-US" sz="2000" dirty="0"/>
-              <a:t>Direct link to the Moodle Quiz for the Day</a:t>
-            </a:r>
-          </a:p>
-        </p:txBody>
-      </p:sp>
-      <p:pic>
-        <p:nvPicPr>
-          <p:cNvPr id="18" name="Picture 17">
-            <a:extLst>
-              <a:ext uri="{FF2B5EF4-FFF2-40B4-BE49-F238E27FC236}">
-                <a16:creationId xmlns:a16="http://schemas.microsoft.com/office/drawing/2014/main" id="{19B249A5-C4E3-C13A-000A-1C50FE03731E}"/>
-              </a:ext>
-            </a:extLst>
-          </p:cNvPr>
-          <p:cNvPicPr>
-            <a:picLocks noChangeAspect="1"/>
-          </p:cNvPicPr>
-          <p:nvPr/>
-        </p:nvPicPr>
-        <p:blipFill>
-          <a:blip r:embed="rId6"/>
-          <a:stretch>
-            <a:fillRect/>
-          </a:stretch>
-        </p:blipFill>
-        <p:spPr>
-          <a:xfrm>
-            <a:off x="3588946" y="5012805"/>
-            <a:ext cx="3186557" cy="585869"/>
-          </a:xfrm>
-          <a:prstGeom prst="rect">
-            <a:avLst/>
-          </a:prstGeom>
-        </p:spPr>
-      </p:pic>
-    </p:spTree>
-    <p:extLst>
-      <p:ext uri="{BB962C8B-B14F-4D97-AF65-F5344CB8AC3E}">
-        <p14:creationId xmlns:p14="http://schemas.microsoft.com/office/powerpoint/2010/main" val="3678158814"/>
-      </p:ext>
-    </p:extLst>
-  </p:cSld>
-  <p:clrMapOvr>
-    <a:masterClrMapping/>
-  </p:clrMapOvr>
-  <p:transition spd="med"/>
-</p:sld>
-</file>
-
-<file path=ppt/slides/slide2.xml><?xml version="1.0" encoding="utf-8"?>
-<p:sld xmlns:a="http://schemas.openxmlformats.org/drawingml/2006/main" xmlns:r="http://schemas.openxmlformats.org/officeDocument/2006/relationships" xmlns:p="http://schemas.openxmlformats.org/presentationml/2006/main">
-  <p:cSld>
-    <p:spTree>
-      <p:nvGrpSpPr>
-        <p:cNvPr id="1" name=""/>
-        <p:cNvGrpSpPr/>
-        <p:nvPr/>
-      </p:nvGrpSpPr>
-      <p:grpSpPr>
-        <a:xfrm>
-          <a:off x="0" y="0"/>
-          <a:ext cx="0" cy="0"/>
-          <a:chOff x="0" y="0"/>
-          <a:chExt cx="0" cy="0"/>
-        </a:xfrm>
-      </p:grpSpPr>
-      <p:pic>
-        <p:nvPicPr>
-          <p:cNvPr id="9" name="Picture 8">
-            <a:extLst>
-              <a:ext uri="{FF2B5EF4-FFF2-40B4-BE49-F238E27FC236}">
-                <a16:creationId xmlns:a16="http://schemas.microsoft.com/office/drawing/2014/main" id="{B696A0FF-BFBB-03DE-B552-0DEF46873967}"/>
-              </a:ext>
-            </a:extLst>
-          </p:cNvPr>
-          <p:cNvPicPr>
-            <a:picLocks noChangeAspect="1"/>
-          </p:cNvPicPr>
-          <p:nvPr/>
-        </p:nvPicPr>
-        <p:blipFill>
-          <a:blip r:embed="rId3"/>
-          <a:stretch>
-            <a:fillRect/>
-          </a:stretch>
-        </p:blipFill>
-        <p:spPr>
-          <a:xfrm>
-            <a:off x="-29308" y="2286000"/>
-            <a:ext cx="9144000" cy="3500208"/>
-          </a:xfrm>
-          <a:prstGeom prst="rect">
-            <a:avLst/>
-          </a:prstGeom>
-        </p:spPr>
-      </p:pic>
-      <p:sp>
-        <p:nvSpPr>
-          <p:cNvPr id="2" name="Title 1">
-            <a:extLst>
-              <a:ext uri="{FF2B5EF4-FFF2-40B4-BE49-F238E27FC236}">
-                <a16:creationId xmlns:a16="http://schemas.microsoft.com/office/drawing/2014/main" id="{D9F249E8-0C8F-4F33-9A1D-E5CFEF6DB0BE}"/>
+                <a16:creationId xmlns:a16="http://schemas.microsoft.com/office/drawing/2014/main" id="{661A920A-F5BE-C1C4-B7EB-1246A27407BE}"/>
               </a:ext>
             </a:extLst>
           </p:cNvPr>
@@ -5155,652 +4702,56 @@
           <a:lstStyle/>
           <a:p>
             <a:r>
-              <a:rPr lang="en-US" dirty="0" err="1"/>
-              <a:t>Airtable</a:t>
-            </a:r>
-            <a:r>
-              <a:rPr lang="en-US" dirty="0"/>
-              <a:t> View on Moodle</a:t>
+              <a:rPr lang="en-US" dirty="0">
+                <a:latin typeface="Grandview" panose="020B0502040204020203" pitchFamily="34" charset="0"/>
+              </a:rPr>
+              <a:t>Introduction to Java</a:t>
             </a:r>
           </a:p>
         </p:txBody>
       </p:sp>
       <p:sp>
         <p:nvSpPr>
-          <p:cNvPr id="7" name="Rectangle 6">
+          <p:cNvPr id="3" name="Content Placeholder 2">
             <a:extLst>
               <a:ext uri="{FF2B5EF4-FFF2-40B4-BE49-F238E27FC236}">
-                <a16:creationId xmlns:a16="http://schemas.microsoft.com/office/drawing/2014/main" id="{733BB64D-1067-B903-D5EA-FB1DC3500A26}"/>
+                <a16:creationId xmlns:a16="http://schemas.microsoft.com/office/drawing/2014/main" id="{FDE7B7F9-AB4F-1AB2-F1AF-A4C7424C0038}"/>
               </a:ext>
             </a:extLst>
           </p:cNvPr>
-          <p:cNvSpPr/>
-          <p:nvPr/>
+          <p:cNvSpPr>
+            <a:spLocks noGrp="1"/>
+          </p:cNvSpPr>
+          <p:nvPr>
+            <p:ph idx="1"/>
+          </p:nvPr>
         </p:nvSpPr>
-        <p:spPr>
-          <a:xfrm>
-            <a:off x="7033846" y="3169940"/>
-            <a:ext cx="734925" cy="830995"/>
-          </a:xfrm>
-          <a:prstGeom prst="rect">
-            <a:avLst/>
-          </a:prstGeom>
-          <a:solidFill>
-            <a:srgbClr val="FFFFFF"/>
-          </a:solidFill>
-          <a:ln w="25400" cap="flat">
-            <a:solidFill>
-              <a:srgbClr val="4F81BD"/>
-            </a:solidFill>
-            <a:prstDash val="solid"/>
-            <a:bevel/>
-          </a:ln>
-          <a:effectLst>
-            <a:outerShdw blurRad="38100" dist="23000" dir="5400000" rotWithShape="0">
-              <a:srgbClr val="000000">
-                <a:alpha val="35000"/>
-              </a:srgbClr>
-            </a:outerShdw>
-          </a:effectLst>
-        </p:spPr>
-        <p:style>
-          <a:lnRef idx="0">
-            <a:scrgbClr r="0" g="0" b="0"/>
-          </a:lnRef>
-          <a:fillRef idx="0">
-            <a:scrgbClr r="0" g="0" b="0"/>
-          </a:fillRef>
-          <a:effectRef idx="0">
-            <a:scrgbClr r="0" g="0" b="0"/>
-          </a:effectRef>
-          <a:fontRef idx="none"/>
-        </p:style>
+        <p:spPr/>
         <p:txBody>
-          <a:bodyPr rot="0" spcFirstLastPara="1" vertOverflow="overflow" horzOverflow="overflow" vert="horz" wrap="square" lIns="45719" tIns="45719" rIns="45719" bIns="45719" numCol="1" spcCol="38100" rtlCol="0" anchor="ctr">
-            <a:spAutoFit/>
-          </a:bodyPr>
+          <a:bodyPr/>
           <a:lstStyle/>
           <a:p>
-            <a:pPr marL="0" marR="0" indent="0" algn="ctr" defTabSz="914400" rtl="0" fontAlgn="auto" latinLnBrk="1" hangingPunct="0">
-              <a:lnSpc>
-                <a:spcPct val="100000"/>
-              </a:lnSpc>
-              <a:spcBef>
-                <a:spcPts val="0"/>
-              </a:spcBef>
-              <a:spcAft>
-                <a:spcPts val="0"/>
-              </a:spcAft>
-              <a:buClrTx/>
-              <a:buSzTx/>
-              <a:buFontTx/>
-              <a:buNone/>
-              <a:tabLst/>
-            </a:pPr>
-            <a:r>
-              <a:rPr lang="en-US" sz="1600" dirty="0">
-                <a:solidFill>
-                  <a:srgbClr val="000000"/>
-                </a:solidFill>
+            <a:r>
+              <a:rPr lang="en-US" dirty="0">
+                <a:latin typeface="Grandview" panose="020B0502040204020203" pitchFamily="34" charset="0"/>
               </a:rPr>
-              <a:t>DUE:</a:t>
-            </a:r>
-          </a:p>
-          <a:p>
-            <a:pPr marL="0" marR="0" indent="0" algn="ctr" defTabSz="914400" rtl="0" fontAlgn="auto" latinLnBrk="1" hangingPunct="0">
-              <a:lnSpc>
-                <a:spcPct val="100000"/>
-              </a:lnSpc>
-              <a:spcBef>
-                <a:spcPts val="0"/>
-              </a:spcBef>
-              <a:spcAft>
-                <a:spcPts val="0"/>
-              </a:spcAft>
-              <a:buClrTx/>
-              <a:buSzTx/>
-              <a:buFontTx/>
-              <a:buNone/>
-              <a:tabLst/>
-            </a:pPr>
-            <a:r>
-              <a:rPr kumimoji="0" lang="en-US" sz="1600" b="0" i="0" u="none" strike="noStrike" cap="none" spc="0" normalizeH="0" baseline="0" dirty="0">
-                <a:ln>
-                  <a:noFill/>
-                </a:ln>
-                <a:solidFill>
-                  <a:srgbClr val="000000"/>
-                </a:solidFill>
-                <a:effectLst/>
-                <a:uFillTx/>
-                <a:latin typeface="Calibri"/>
-                <a:ea typeface="Calibri"/>
-                <a:cs typeface="Calibri"/>
-                <a:sym typeface="Calibri"/>
+              <a:t>Work through the handout, asking questions as needed</a:t>
+            </a:r>
+          </a:p>
+          <a:p>
+            <a:r>
+              <a:rPr lang="en-US" dirty="0">
+                <a:latin typeface="Grandview" panose="020B0502040204020203" pitchFamily="34" charset="0"/>
               </a:rPr>
-              <a:t>Last</a:t>
-            </a:r>
-          </a:p>
-          <a:p>
-            <a:pPr marL="0" marR="0" indent="0" algn="ctr" defTabSz="914400" rtl="0" fontAlgn="auto" latinLnBrk="1" hangingPunct="0">
-              <a:lnSpc>
-                <a:spcPct val="100000"/>
-              </a:lnSpc>
-              <a:spcBef>
-                <a:spcPts val="0"/>
-              </a:spcBef>
-              <a:spcAft>
-                <a:spcPts val="0"/>
-              </a:spcAft>
-              <a:buClrTx/>
-              <a:buSzTx/>
-              <a:buFontTx/>
-              <a:buNone/>
-              <a:tabLst/>
-            </a:pPr>
-            <a:r>
-              <a:rPr lang="en-US" sz="1600" dirty="0">
-                <a:solidFill>
-                  <a:srgbClr val="000000"/>
-                </a:solidFill>
-              </a:rPr>
-              <a:t>Day</a:t>
-            </a:r>
-            <a:endParaRPr kumimoji="0" lang="en-US" sz="1600" b="0" i="0" u="none" strike="noStrike" cap="none" spc="0" normalizeH="0" baseline="0" dirty="0">
-              <a:ln>
-                <a:noFill/>
-              </a:ln>
-              <a:solidFill>
-                <a:srgbClr val="000000"/>
-              </a:solidFill>
-              <a:effectLst/>
-              <a:uFillTx/>
-              <a:latin typeface="Calibri"/>
-              <a:ea typeface="Calibri"/>
-              <a:cs typeface="Calibri"/>
-              <a:sym typeface="Calibri"/>
-            </a:endParaRPr>
-          </a:p>
-        </p:txBody>
-      </p:sp>
-      <p:sp>
-        <p:nvSpPr>
-          <p:cNvPr id="8" name="Rectangle 7">
-            <a:extLst>
-              <a:ext uri="{FF2B5EF4-FFF2-40B4-BE49-F238E27FC236}">
-                <a16:creationId xmlns:a16="http://schemas.microsoft.com/office/drawing/2014/main" id="{C550C031-9A92-9F5A-1DD1-CEED4E41DC69}"/>
-              </a:ext>
-            </a:extLst>
-          </p:cNvPr>
-          <p:cNvSpPr/>
-          <p:nvPr/>
-        </p:nvSpPr>
-        <p:spPr>
-          <a:xfrm>
-            <a:off x="3147646" y="1941710"/>
-            <a:ext cx="734925" cy="830995"/>
-          </a:xfrm>
-          <a:prstGeom prst="rect">
-            <a:avLst/>
-          </a:prstGeom>
-          <a:solidFill>
-            <a:srgbClr val="FFFFFF"/>
-          </a:solidFill>
-          <a:ln w="25400" cap="flat">
-            <a:solidFill>
-              <a:srgbClr val="4F81BD"/>
-            </a:solidFill>
-            <a:prstDash val="solid"/>
-            <a:bevel/>
-          </a:ln>
-          <a:effectLst>
-            <a:outerShdw blurRad="38100" dist="23000" dir="5400000" rotWithShape="0">
-              <a:srgbClr val="000000">
-                <a:alpha val="35000"/>
-              </a:srgbClr>
-            </a:outerShdw>
-          </a:effectLst>
-        </p:spPr>
-        <p:style>
-          <a:lnRef idx="0">
-            <a:scrgbClr r="0" g="0" b="0"/>
-          </a:lnRef>
-          <a:fillRef idx="0">
-            <a:scrgbClr r="0" g="0" b="0"/>
-          </a:fillRef>
-          <a:effectRef idx="0">
-            <a:scrgbClr r="0" g="0" b="0"/>
-          </a:effectRef>
-          <a:fontRef idx="none"/>
-        </p:style>
-        <p:txBody>
-          <a:bodyPr rot="0" spcFirstLastPara="1" vertOverflow="overflow" horzOverflow="overflow" vert="horz" wrap="square" lIns="45719" tIns="45719" rIns="45719" bIns="45719" numCol="1" spcCol="38100" rtlCol="0" anchor="ctr">
-            <a:spAutoFit/>
-          </a:bodyPr>
-          <a:lstStyle/>
-          <a:p>
-            <a:pPr marL="0" marR="0" indent="0" algn="ctr" defTabSz="914400" rtl="0" fontAlgn="auto" latinLnBrk="1" hangingPunct="0">
-              <a:lnSpc>
-                <a:spcPct val="100000"/>
-              </a:lnSpc>
-              <a:spcBef>
-                <a:spcPts val="0"/>
-              </a:spcBef>
-              <a:spcAft>
-                <a:spcPts val="0"/>
-              </a:spcAft>
-              <a:buClrTx/>
-              <a:buSzTx/>
-              <a:buFontTx/>
-              <a:buNone/>
-              <a:tabLst/>
-            </a:pPr>
-            <a:r>
-              <a:rPr lang="en-US" sz="1600" dirty="0">
-                <a:solidFill>
-                  <a:srgbClr val="000000"/>
-                </a:solidFill>
-              </a:rPr>
-              <a:t>DUE:</a:t>
-            </a:r>
-          </a:p>
-          <a:p>
-            <a:pPr marL="0" marR="0" indent="0" algn="ctr" defTabSz="914400" rtl="0" fontAlgn="auto" latinLnBrk="1" hangingPunct="0">
-              <a:lnSpc>
-                <a:spcPct val="100000"/>
-              </a:lnSpc>
-              <a:spcBef>
-                <a:spcPts val="0"/>
-              </a:spcBef>
-              <a:spcAft>
-                <a:spcPts val="0"/>
-              </a:spcAft>
-              <a:buClrTx/>
-              <a:buSzTx/>
-              <a:buFontTx/>
-              <a:buNone/>
-              <a:tabLst/>
-            </a:pPr>
-            <a:r>
-              <a:rPr kumimoji="0" lang="en-US" sz="1600" b="0" i="0" u="none" strike="noStrike" cap="none" spc="0" normalizeH="0" baseline="0" dirty="0">
-                <a:ln>
-                  <a:noFill/>
-                </a:ln>
-                <a:solidFill>
-                  <a:srgbClr val="000000"/>
-                </a:solidFill>
-                <a:effectLst/>
-                <a:uFillTx/>
-                <a:latin typeface="Calibri"/>
-                <a:ea typeface="Calibri"/>
-                <a:cs typeface="Calibri"/>
-                <a:sym typeface="Calibri"/>
-              </a:rPr>
-              <a:t>Last</a:t>
-            </a:r>
-          </a:p>
-          <a:p>
-            <a:pPr marL="0" marR="0" indent="0" algn="ctr" defTabSz="914400" rtl="0" fontAlgn="auto" latinLnBrk="1" hangingPunct="0">
-              <a:lnSpc>
-                <a:spcPct val="100000"/>
-              </a:lnSpc>
-              <a:spcBef>
-                <a:spcPts val="0"/>
-              </a:spcBef>
-              <a:spcAft>
-                <a:spcPts val="0"/>
-              </a:spcAft>
-              <a:buClrTx/>
-              <a:buSzTx/>
-              <a:buFontTx/>
-              <a:buNone/>
-              <a:tabLst/>
-            </a:pPr>
-            <a:r>
-              <a:rPr lang="en-US" sz="1600" dirty="0">
-                <a:solidFill>
-                  <a:srgbClr val="000000"/>
-                </a:solidFill>
-              </a:rPr>
-              <a:t>Day</a:t>
-            </a:r>
-            <a:endParaRPr kumimoji="0" lang="en-US" sz="1600" b="0" i="0" u="none" strike="noStrike" cap="none" spc="0" normalizeH="0" baseline="0" dirty="0">
-              <a:ln>
-                <a:noFill/>
-              </a:ln>
-              <a:solidFill>
-                <a:srgbClr val="000000"/>
-              </a:solidFill>
-              <a:effectLst/>
-              <a:uFillTx/>
-              <a:latin typeface="Calibri"/>
-              <a:ea typeface="Calibri"/>
-              <a:cs typeface="Calibri"/>
-              <a:sym typeface="Calibri"/>
-            </a:endParaRPr>
-          </a:p>
-        </p:txBody>
-      </p:sp>
-      <p:sp>
-        <p:nvSpPr>
-          <p:cNvPr id="11" name="Rectangle 10">
-            <a:extLst>
-              <a:ext uri="{FF2B5EF4-FFF2-40B4-BE49-F238E27FC236}">
-                <a16:creationId xmlns:a16="http://schemas.microsoft.com/office/drawing/2014/main" id="{04959BCE-04DD-1B36-2FB7-F28BA441C561}"/>
-              </a:ext>
-            </a:extLst>
-          </p:cNvPr>
-          <p:cNvSpPr/>
-          <p:nvPr/>
-        </p:nvSpPr>
-        <p:spPr>
-          <a:xfrm>
-            <a:off x="1763905" y="3812213"/>
-            <a:ext cx="734925" cy="830995"/>
-          </a:xfrm>
-          <a:prstGeom prst="rect">
-            <a:avLst/>
-          </a:prstGeom>
-          <a:solidFill>
-            <a:srgbClr val="FFFFFF"/>
-          </a:solidFill>
-          <a:ln w="25400" cap="flat">
-            <a:solidFill>
-              <a:srgbClr val="4F81BD"/>
-            </a:solidFill>
-            <a:prstDash val="solid"/>
-            <a:bevel/>
-          </a:ln>
-          <a:effectLst>
-            <a:outerShdw blurRad="38100" dist="23000" dir="5400000" rotWithShape="0">
-              <a:srgbClr val="000000">
-                <a:alpha val="35000"/>
-              </a:srgbClr>
-            </a:outerShdw>
-          </a:effectLst>
-        </p:spPr>
-        <p:style>
-          <a:lnRef idx="0">
-            <a:scrgbClr r="0" g="0" b="0"/>
-          </a:lnRef>
-          <a:fillRef idx="0">
-            <a:scrgbClr r="0" g="0" b="0"/>
-          </a:fillRef>
-          <a:effectRef idx="0">
-            <a:scrgbClr r="0" g="0" b="0"/>
-          </a:effectRef>
-          <a:fontRef idx="none"/>
-        </p:style>
-        <p:txBody>
-          <a:bodyPr rot="0" spcFirstLastPara="1" vertOverflow="overflow" horzOverflow="overflow" vert="horz" wrap="square" lIns="45719" tIns="45719" rIns="45719" bIns="45719" numCol="1" spcCol="38100" rtlCol="0" anchor="ctr">
-            <a:spAutoFit/>
-          </a:bodyPr>
-          <a:lstStyle/>
-          <a:p>
-            <a:pPr marL="0" marR="0" indent="0" algn="ctr" defTabSz="914400" rtl="0" fontAlgn="auto" latinLnBrk="1" hangingPunct="0">
-              <a:lnSpc>
-                <a:spcPct val="100000"/>
-              </a:lnSpc>
-              <a:spcBef>
-                <a:spcPts val="0"/>
-              </a:spcBef>
-              <a:spcAft>
-                <a:spcPts val="0"/>
-              </a:spcAft>
-              <a:buClrTx/>
-              <a:buSzTx/>
-              <a:buFontTx/>
-              <a:buNone/>
-              <a:tabLst/>
-            </a:pPr>
-            <a:r>
-              <a:rPr lang="en-US" sz="1600" dirty="0">
-                <a:solidFill>
-                  <a:srgbClr val="000000"/>
-                </a:solidFill>
-              </a:rPr>
-              <a:t>DUE:</a:t>
-            </a:r>
-          </a:p>
-          <a:p>
-            <a:pPr marL="0" marR="0" indent="0" algn="ctr" defTabSz="914400" rtl="0" fontAlgn="auto" latinLnBrk="1" hangingPunct="0">
-              <a:lnSpc>
-                <a:spcPct val="100000"/>
-              </a:lnSpc>
-              <a:spcBef>
-                <a:spcPts val="0"/>
-              </a:spcBef>
-              <a:spcAft>
-                <a:spcPts val="0"/>
-              </a:spcAft>
-              <a:buClrTx/>
-              <a:buSzTx/>
-              <a:buFontTx/>
-              <a:buNone/>
-              <a:tabLst/>
-            </a:pPr>
-            <a:r>
-              <a:rPr kumimoji="0" lang="en-US" sz="1600" b="0" i="0" u="none" strike="noStrike" cap="none" spc="0" normalizeH="0" baseline="0" dirty="0">
-                <a:ln>
-                  <a:noFill/>
-                </a:ln>
-                <a:solidFill>
-                  <a:srgbClr val="000000"/>
-                </a:solidFill>
-                <a:effectLst/>
-                <a:uFillTx/>
-                <a:latin typeface="Calibri"/>
-                <a:ea typeface="Calibri"/>
-                <a:cs typeface="Calibri"/>
-                <a:sym typeface="Calibri"/>
-              </a:rPr>
-              <a:t>Last</a:t>
-            </a:r>
-          </a:p>
-          <a:p>
-            <a:pPr marL="0" marR="0" indent="0" algn="ctr" defTabSz="914400" rtl="0" fontAlgn="auto" latinLnBrk="1" hangingPunct="0">
-              <a:lnSpc>
-                <a:spcPct val="100000"/>
-              </a:lnSpc>
-              <a:spcBef>
-                <a:spcPts val="0"/>
-              </a:spcBef>
-              <a:spcAft>
-                <a:spcPts val="0"/>
-              </a:spcAft>
-              <a:buClrTx/>
-              <a:buSzTx/>
-              <a:buFontTx/>
-              <a:buNone/>
-              <a:tabLst/>
-            </a:pPr>
-            <a:r>
-              <a:rPr lang="en-US" sz="1600" dirty="0">
-                <a:solidFill>
-                  <a:srgbClr val="000000"/>
-                </a:solidFill>
-              </a:rPr>
-              <a:t>Day</a:t>
-            </a:r>
-            <a:endParaRPr kumimoji="0" lang="en-US" sz="1600" b="0" i="0" u="none" strike="noStrike" cap="none" spc="0" normalizeH="0" baseline="0" dirty="0">
-              <a:ln>
-                <a:noFill/>
-              </a:ln>
-              <a:solidFill>
-                <a:srgbClr val="000000"/>
-              </a:solidFill>
-              <a:effectLst/>
-              <a:uFillTx/>
-              <a:latin typeface="Calibri"/>
-              <a:ea typeface="Calibri"/>
-              <a:cs typeface="Calibri"/>
-              <a:sym typeface="Calibri"/>
-            </a:endParaRPr>
-          </a:p>
-        </p:txBody>
-      </p:sp>
-      <p:sp>
-        <p:nvSpPr>
-          <p:cNvPr id="12" name="Rectangle 11">
-            <a:extLst>
-              <a:ext uri="{FF2B5EF4-FFF2-40B4-BE49-F238E27FC236}">
-                <a16:creationId xmlns:a16="http://schemas.microsoft.com/office/drawing/2014/main" id="{ABAE678F-E869-E57B-2CE0-C27AA47E3248}"/>
-              </a:ext>
-            </a:extLst>
-          </p:cNvPr>
-          <p:cNvSpPr/>
-          <p:nvPr/>
-        </p:nvSpPr>
-        <p:spPr>
-          <a:xfrm>
-            <a:off x="5738446" y="5278634"/>
-            <a:ext cx="734925" cy="830995"/>
-          </a:xfrm>
-          <a:prstGeom prst="rect">
-            <a:avLst/>
-          </a:prstGeom>
-          <a:solidFill>
-            <a:srgbClr val="FFFFFF"/>
-          </a:solidFill>
-          <a:ln w="25400" cap="flat">
-            <a:solidFill>
-              <a:srgbClr val="4F81BD"/>
-            </a:solidFill>
-            <a:prstDash val="solid"/>
-            <a:bevel/>
-          </a:ln>
-          <a:effectLst>
-            <a:outerShdw blurRad="38100" dist="23000" dir="5400000" rotWithShape="0">
-              <a:srgbClr val="000000">
-                <a:alpha val="35000"/>
-              </a:srgbClr>
-            </a:outerShdw>
-          </a:effectLst>
-        </p:spPr>
-        <p:style>
-          <a:lnRef idx="0">
-            <a:scrgbClr r="0" g="0" b="0"/>
-          </a:lnRef>
-          <a:fillRef idx="0">
-            <a:scrgbClr r="0" g="0" b="0"/>
-          </a:fillRef>
-          <a:effectRef idx="0">
-            <a:scrgbClr r="0" g="0" b="0"/>
-          </a:effectRef>
-          <a:fontRef idx="none"/>
-        </p:style>
-        <p:txBody>
-          <a:bodyPr rot="0" spcFirstLastPara="1" vertOverflow="overflow" horzOverflow="overflow" vert="horz" wrap="square" lIns="45719" tIns="45719" rIns="45719" bIns="45719" numCol="1" spcCol="38100" rtlCol="0" anchor="ctr">
-            <a:spAutoFit/>
-          </a:bodyPr>
-          <a:lstStyle/>
-          <a:p>
-            <a:pPr marL="0" marR="0" indent="0" algn="ctr" defTabSz="914400" rtl="0" fontAlgn="auto" latinLnBrk="1" hangingPunct="0">
-              <a:lnSpc>
-                <a:spcPct val="100000"/>
-              </a:lnSpc>
-              <a:spcBef>
-                <a:spcPts val="0"/>
-              </a:spcBef>
-              <a:spcAft>
-                <a:spcPts val="0"/>
-              </a:spcAft>
-              <a:buClrTx/>
-              <a:buSzTx/>
-              <a:buFontTx/>
-              <a:buNone/>
-              <a:tabLst/>
-            </a:pPr>
-            <a:r>
-              <a:rPr lang="en-US" sz="1600" dirty="0">
-                <a:solidFill>
-                  <a:srgbClr val="000000"/>
-                </a:solidFill>
-              </a:rPr>
-              <a:t>DUE:</a:t>
-            </a:r>
-          </a:p>
-          <a:p>
-            <a:pPr marL="0" marR="0" indent="0" algn="ctr" defTabSz="914400" rtl="0" fontAlgn="auto" latinLnBrk="1" hangingPunct="0">
-              <a:lnSpc>
-                <a:spcPct val="100000"/>
-              </a:lnSpc>
-              <a:spcBef>
-                <a:spcPts val="0"/>
-              </a:spcBef>
-              <a:spcAft>
-                <a:spcPts val="0"/>
-              </a:spcAft>
-              <a:buClrTx/>
-              <a:buSzTx/>
-              <a:buFontTx/>
-              <a:buNone/>
-              <a:tabLst/>
-            </a:pPr>
-            <a:r>
-              <a:rPr kumimoji="0" lang="en-US" sz="1600" b="0" i="0" u="none" strike="noStrike" cap="none" spc="0" normalizeH="0" baseline="0" dirty="0">
-                <a:ln>
-                  <a:noFill/>
-                </a:ln>
-                <a:solidFill>
-                  <a:srgbClr val="000000"/>
-                </a:solidFill>
-                <a:effectLst/>
-                <a:uFillTx/>
-                <a:latin typeface="Calibri"/>
-                <a:ea typeface="Calibri"/>
-                <a:cs typeface="Calibri"/>
-                <a:sym typeface="Calibri"/>
-              </a:rPr>
-              <a:t>Last</a:t>
-            </a:r>
-          </a:p>
-          <a:p>
-            <a:pPr marL="0" marR="0" indent="0" algn="ctr" defTabSz="914400" rtl="0" fontAlgn="auto" latinLnBrk="1" hangingPunct="0">
-              <a:lnSpc>
-                <a:spcPct val="100000"/>
-              </a:lnSpc>
-              <a:spcBef>
-                <a:spcPts val="0"/>
-              </a:spcBef>
-              <a:spcAft>
-                <a:spcPts val="0"/>
-              </a:spcAft>
-              <a:buClrTx/>
-              <a:buSzTx/>
-              <a:buFontTx/>
-              <a:buNone/>
-              <a:tabLst/>
-            </a:pPr>
-            <a:r>
-              <a:rPr lang="en-US" sz="1600" dirty="0">
-                <a:solidFill>
-                  <a:srgbClr val="000000"/>
-                </a:solidFill>
-              </a:rPr>
-              <a:t>Day</a:t>
-            </a:r>
-            <a:endParaRPr kumimoji="0" lang="en-US" sz="1600" b="0" i="0" u="none" strike="noStrike" cap="none" spc="0" normalizeH="0" baseline="0" dirty="0">
-              <a:ln>
-                <a:noFill/>
-              </a:ln>
-              <a:solidFill>
-                <a:srgbClr val="000000"/>
-              </a:solidFill>
-              <a:effectLst/>
-              <a:uFillTx/>
-              <a:latin typeface="Calibri"/>
-              <a:ea typeface="Calibri"/>
-              <a:cs typeface="Calibri"/>
-              <a:sym typeface="Calibri"/>
-            </a:endParaRPr>
+              <a:t>Pause after Part 3 and check in with me</a:t>
+            </a:r>
           </a:p>
         </p:txBody>
       </p:sp>
     </p:spTree>
     <p:extLst>
       <p:ext uri="{BB962C8B-B14F-4D97-AF65-F5344CB8AC3E}">
-        <p14:creationId xmlns:p14="http://schemas.microsoft.com/office/powerpoint/2010/main" val="3221831349"/>
+        <p14:creationId xmlns:p14="http://schemas.microsoft.com/office/powerpoint/2010/main" val="2392066996"/>
       </p:ext>
     </p:extLst>
   </p:cSld>
@@ -5812,7 +4763,7 @@
 </file>
 
 <file path=ppt/slides/slide3.xml><?xml version="1.0" encoding="utf-8"?>
-<p:sld xmlns:a="http://schemas.openxmlformats.org/drawingml/2006/main" xmlns:r="http://schemas.openxmlformats.org/officeDocument/2006/relationships" xmlns:p="http://schemas.openxmlformats.org/presentationml/2006/main">
+<p:sld xmlns:a="http://schemas.openxmlformats.org/drawingml/2006/main" xmlns:r="http://schemas.openxmlformats.org/officeDocument/2006/relationships" xmlns:p="http://schemas.openxmlformats.org/presentationml/2006/main" show="0">
   <p:cSld>
     <p:spTree>
       <p:nvGrpSpPr>
@@ -7841,76 +6792,91 @@
             </a:r>
           </a:p>
           <a:p>
-            <a:pPr lvl="1"/>
-            <a:r>
-              <a:rPr lang="en-US" sz="2000" dirty="0" err="1"/>
-              <a:t>ConditionalExamples.java</a:t>
-            </a:r>
-            <a:endParaRPr lang="en-US" sz="2000" dirty="0"/>
-          </a:p>
-          <a:p>
-            <a:pPr lvl="1"/>
-            <a:r>
-              <a:rPr lang="en-US" sz="2000" dirty="0"/>
-              <a:t>LoopProbs.java</a:t>
-            </a:r>
-          </a:p>
-          <a:p>
-            <a:r>
-              <a:rPr lang="en-US" sz="2400" dirty="0"/>
-              <a:t>Each file contains several solved functions and several unsolved functions.  Understand the code in the solved functions, and then use that code to help you write the unsolved functions.</a:t>
-            </a:r>
-          </a:p>
-          <a:p>
-            <a:r>
-              <a:rPr lang="en-US" sz="2400" dirty="0"/>
-              <a:t>If you have a problem that you can’t quickly debug, or need a hint – call me or the TA over</a:t>
-            </a:r>
-          </a:p>
-          <a:p>
-            <a:r>
-              <a:rPr lang="en-US" sz="2400" dirty="0"/>
-              <a:t>Test your code to ensure you’re right</a:t>
-            </a:r>
-          </a:p>
-          <a:p>
-            <a:pPr lvl="1"/>
-            <a:r>
-              <a:rPr lang="en-US" sz="2400" dirty="0"/>
-              <a:t>In ConditionalExamples.java, modify “main” to call your new functions with test values</a:t>
-            </a:r>
-            <a:r>
-              <a:rPr lang="en-US" sz="2400" i="1" dirty="0"/>
-              <a:t> (print to see results)</a:t>
-            </a:r>
-          </a:p>
-          <a:p>
             <a:pPr marL="457200" lvl="1" indent="0">
               <a:buNone/>
             </a:pPr>
+            <a:r>
+              <a:rPr lang="en-US" sz="2000" dirty="0"/>
+              <a:t>ConditionalExamples.java, LoopProbs.java, and LoopProbsTest.java</a:t>
+            </a:r>
+          </a:p>
+          <a:p>
+            <a:r>
+              <a:rPr lang="en-US" sz="2400" dirty="0"/>
+              <a:t>The first two contain several solved and unsolved functions.</a:t>
+            </a:r>
+          </a:p>
+          <a:p>
+            <a:r>
+              <a:rPr lang="en-US" sz="2400" dirty="0"/>
+              <a:t>If you have a problem that you can’t quickly debug, or need a hint – call me or the TA over</a:t>
+            </a:r>
+          </a:p>
+          <a:p>
+            <a:r>
+              <a:rPr lang="en-US" sz="2400" dirty="0"/>
+              <a:t>Test your code to ensure you’re right using the green “Play” buttons</a:t>
+            </a:r>
+          </a:p>
+          <a:p>
+            <a:pPr lvl="1"/>
+            <a:r>
+              <a:rPr lang="en-US" sz="2400" dirty="0"/>
+              <a:t>In ConditionalExamples.java, </a:t>
+            </a:r>
+            <a:br>
+              <a:rPr lang="en-US" sz="2400" dirty="0"/>
+            </a:br>
+            <a:r>
+              <a:rPr lang="en-US" sz="2400" dirty="0"/>
+              <a:t>modify “main” to call your</a:t>
+            </a:r>
+            <a:br>
+              <a:rPr lang="en-US" sz="2400" dirty="0"/>
+            </a:br>
+            <a:r>
+              <a:rPr lang="en-US" sz="2400" dirty="0"/>
+              <a:t>new functions with </a:t>
+            </a:r>
+            <a:br>
+              <a:rPr lang="en-US" sz="2400" dirty="0"/>
+            </a:br>
+            <a:r>
+              <a:rPr lang="en-US" sz="2400" dirty="0"/>
+              <a:t>test values</a:t>
+            </a:r>
+            <a:r>
+              <a:rPr lang="en-US" sz="2400" i="1" dirty="0"/>
+              <a:t> </a:t>
+            </a:r>
+            <a:br>
+              <a:rPr lang="en-US" sz="2400" i="1" dirty="0"/>
+            </a:br>
+            <a:r>
+              <a:rPr lang="en-US" sz="2400" i="1" dirty="0"/>
+              <a:t>(print to see results)</a:t>
+            </a:r>
             <a:endParaRPr lang="en-US" sz="2800" i="1" dirty="0"/>
           </a:p>
           <a:p>
             <a:pPr lvl="1"/>
             <a:r>
               <a:rPr lang="en-US" sz="2400" dirty="0"/>
-              <a:t>For </a:t>
-            </a:r>
-            <a:r>
-              <a:rPr lang="en-US" sz="2400" dirty="0" err="1"/>
-              <a:t>LoopProbs.java</a:t>
-            </a:r>
-            <a:r>
+              <a:t>For LoopProbs.java, </a:t>
+            </a:r>
+            <a:br>
               <a:rPr lang="en-US" sz="2400" dirty="0"/>
-              <a:t>, run the </a:t>
-            </a:r>
-            <a:r>
-              <a:rPr lang="en-US" sz="2400" dirty="0" err="1"/>
-              <a:t>LoopProbsTest.java</a:t>
-            </a:r>
+            </a:br>
             <a:r>
               <a:rPr lang="en-US" sz="2400" dirty="0"/>
-              <a:t> file as Junit Test</a:t>
+              <a:t>run the LoopProbsTest.java </a:t>
+            </a:r>
+            <a:br>
+              <a:rPr lang="en-US" sz="2400" dirty="0"/>
+            </a:br>
+            <a:r>
+              <a:rPr lang="en-US" sz="2400" dirty="0"/>
+              <a:t>file (as JUnit Test)</a:t>
             </a:r>
           </a:p>
           <a:p>
@@ -7923,10 +6889,10 @@
       </p:sp>
       <p:pic>
         <p:nvPicPr>
-          <p:cNvPr id="11" name="Picture 10">
+          <p:cNvPr id="6" name="Picture 5">
             <a:extLst>
               <a:ext uri="{FF2B5EF4-FFF2-40B4-BE49-F238E27FC236}">
-                <a16:creationId xmlns:a16="http://schemas.microsoft.com/office/drawing/2014/main" id="{AA54B7F2-B30F-0001-A7FE-1955A99DA415}"/>
+                <a16:creationId xmlns:a16="http://schemas.microsoft.com/office/drawing/2014/main" id="{37853D02-F123-8A23-A911-F42F428A17C9}"/>
               </a:ext>
             </a:extLst>
           </p:cNvPr>
@@ -7937,14 +6903,15 @@
         </p:nvPicPr>
         <p:blipFill>
           <a:blip r:embed="rId3"/>
+          <a:srcRect t="1" r="41624" b="11109"/>
           <a:stretch>
             <a:fillRect/>
           </a:stretch>
         </p:blipFill>
         <p:spPr>
           <a:xfrm>
-            <a:off x="1827779" y="5257800"/>
-            <a:ext cx="7316221" cy="514422"/>
+            <a:off x="4713475" y="3581400"/>
+            <a:ext cx="4232017" cy="1219391"/>
           </a:xfrm>
           <a:prstGeom prst="rect">
             <a:avLst/>
@@ -7953,10 +6920,10 @@
       </p:pic>
       <p:pic>
         <p:nvPicPr>
-          <p:cNvPr id="4" name="Picture 3">
+          <p:cNvPr id="8" name="Picture 7">
             <a:extLst>
               <a:ext uri="{FF2B5EF4-FFF2-40B4-BE49-F238E27FC236}">
-                <a16:creationId xmlns:a16="http://schemas.microsoft.com/office/drawing/2014/main" id="{E34FA46F-443C-7E59-1753-73CA28B653EE}"/>
+                <a16:creationId xmlns:a16="http://schemas.microsoft.com/office/drawing/2014/main" id="{5AF734C0-B182-1109-798C-99193064366A}"/>
               </a:ext>
             </a:extLst>
           </p:cNvPr>
@@ -7973,8 +6940,8 @@
         </p:blipFill>
         <p:spPr>
           <a:xfrm>
-            <a:off x="3035300" y="6309232"/>
-            <a:ext cx="6108700" cy="482600"/>
+            <a:off x="4713475" y="5410200"/>
+            <a:ext cx="4186715" cy="1061421"/>
           </a:xfrm>
           <a:prstGeom prst="rect">
             <a:avLst/>
@@ -8062,22 +7029,57 @@
             </a:r>
           </a:p>
           <a:p>
+            <a:pPr lvl="1"/>
+            <a:r>
+              <a:rPr lang="en-US" dirty="0"/>
+              <a:t>You’ll see errors/output in the console:</a:t>
+            </a:r>
+          </a:p>
+          <a:p>
+            <a:pPr lvl="1"/>
             <a:endParaRPr lang="en-US" dirty="0"/>
           </a:p>
           <a:p>
+            <a:pPr marL="457200" lvl="1" indent="0">
+              <a:buNone/>
+            </a:pPr>
+            <a:endParaRPr lang="en-US" dirty="0"/>
+          </a:p>
+          <a:p>
             <a:r>
               <a:rPr lang="en-US" dirty="0"/>
-              <a:t>When running as a Junit Test all tests run:</a:t>
+              <a:t>When running as a JUnit Test, all tests run</a:t>
+            </a:r>
+          </a:p>
+          <a:p>
+            <a:pPr lvl="1"/>
+            <a:r>
+              <a:rPr lang="en-US" dirty="0"/>
+              <a:t>You’ll see a summary of </a:t>
+            </a:r>
+            <a:br>
+              <a:rPr lang="en-US" dirty="0"/>
+            </a:br>
+            <a:r>
+              <a:rPr lang="en-US" dirty="0"/>
+              <a:t>which ones passed, and </a:t>
+            </a:r>
+            <a:br>
+              <a:rPr lang="en-US" dirty="0"/>
+            </a:br>
+            <a:r>
+              <a:rPr lang="en-US" dirty="0"/>
+              <a:t>can click each for details:</a:t>
             </a:r>
           </a:p>
         </p:txBody>
       </p:sp>
       <p:pic>
         <p:nvPicPr>
-          <p:cNvPr id="7" name="Picture 6">
+          <p:cNvPr id="6" name="Picture 5">
             <a:extLst>
               <a:ext uri="{FF2B5EF4-FFF2-40B4-BE49-F238E27FC236}">
-                <a16:creationId xmlns:a16="http://schemas.microsoft.com/office/drawing/2014/main" id="{4741B113-CBD0-33F1-F14E-6C5CC95148C8}"/>
+                <a16:creationId xmlns:a16="http://schemas.microsoft.com/office/drawing/2014/main" id="{2A7F4368-4F57-1986-0961-1E25AD69C56A}"/>
               </a:ext>
             </a:extLst>
           </p:cNvPr>
@@ -8094,234 +7096,8 @@
         </p:blipFill>
         <p:spPr>
           <a:xfrm>
-            <a:off x="609600" y="2346709"/>
-            <a:ext cx="7316221" cy="514422"/>
-          </a:xfrm>
-          <a:prstGeom prst="rect">
-            <a:avLst/>
-          </a:prstGeom>
-        </p:spPr>
-      </p:pic>
-      <p:sp>
-        <p:nvSpPr>
-          <p:cNvPr id="8" name="TextBox 7">
-            <a:extLst>
-              <a:ext uri="{FF2B5EF4-FFF2-40B4-BE49-F238E27FC236}">
-                <a16:creationId xmlns:a16="http://schemas.microsoft.com/office/drawing/2014/main" id="{313E4AD2-C764-F151-6FD6-C88F3D6A4481}"/>
-              </a:ext>
-            </a:extLst>
-          </p:cNvPr>
-          <p:cNvSpPr txBox="1"/>
-          <p:nvPr/>
-        </p:nvSpPr>
-        <p:spPr>
-          <a:xfrm>
-            <a:off x="4660137" y="4377304"/>
-            <a:ext cx="4518660" cy="2246767"/>
-          </a:xfrm>
-          <a:prstGeom prst="rect">
-            <a:avLst/>
-          </a:prstGeom>
-          <a:noFill/>
-          <a:ln w="12700" cap="flat">
-            <a:noFill/>
-            <a:miter lim="400000"/>
-          </a:ln>
-          <a:effectLst/>
-        </p:spPr>
-        <p:style>
-          <a:lnRef idx="0">
-            <a:scrgbClr r="0" g="0" b="0"/>
-          </a:lnRef>
-          <a:fillRef idx="0">
-            <a:scrgbClr r="0" g="0" b="0"/>
-          </a:fillRef>
-          <a:effectRef idx="0">
-            <a:scrgbClr r="0" g="0" b="0"/>
-          </a:effectRef>
-          <a:fontRef idx="none"/>
-        </p:style>
-        <p:txBody>
-          <a:bodyPr rot="0" spcFirstLastPara="1" vertOverflow="overflow" horzOverflow="overflow" vert="horz" wrap="square" lIns="45719" tIns="45719" rIns="45719" bIns="45719" numCol="1" spcCol="38100" rtlCol="0" anchor="t">
-            <a:spAutoFit/>
-          </a:bodyPr>
-          <a:lstStyle/>
-          <a:p>
-            <a:pPr marL="0" marR="0" indent="0" algn="l" defTabSz="914400" rtl="0" fontAlgn="auto" latinLnBrk="1" hangingPunct="0">
-              <a:lnSpc>
-                <a:spcPct val="100000"/>
-              </a:lnSpc>
-              <a:spcBef>
-                <a:spcPts val="0"/>
-              </a:spcBef>
-              <a:spcAft>
-                <a:spcPts val="0"/>
-              </a:spcAft>
-              <a:buClrTx/>
-              <a:buSzTx/>
-              <a:buFontTx/>
-              <a:buNone/>
-              <a:tabLst/>
-            </a:pPr>
-            <a:r>
-              <a:rPr kumimoji="0" lang="en-US" sz="2800" b="0" i="0" u="none" strike="noStrike" cap="none" spc="0" normalizeH="0" baseline="0" dirty="0">
-                <a:ln>
-                  <a:noFill/>
-                </a:ln>
-                <a:solidFill>
-                  <a:srgbClr val="000000"/>
-                </a:solidFill>
-                <a:effectLst/>
-                <a:uFillTx/>
-                <a:latin typeface="Calibri"/>
-                <a:ea typeface="Calibri"/>
-                <a:cs typeface="Calibri"/>
-                <a:sym typeface="Calibri"/>
-              </a:rPr>
-              <a:t>Green Check means success</a:t>
-            </a:r>
-          </a:p>
-          <a:p>
-            <a:pPr marL="0" marR="0" indent="0" algn="l" defTabSz="914400" rtl="0" fontAlgn="auto" latinLnBrk="1" hangingPunct="0">
-              <a:lnSpc>
-                <a:spcPct val="100000"/>
-              </a:lnSpc>
-              <a:spcBef>
-                <a:spcPts val="0"/>
-              </a:spcBef>
-              <a:spcAft>
-                <a:spcPts val="0"/>
-              </a:spcAft>
-              <a:buClrTx/>
-              <a:buSzTx/>
-              <a:buFontTx/>
-              <a:buNone/>
-              <a:tabLst/>
-            </a:pPr>
-            <a:endParaRPr kumimoji="0" lang="en-US" sz="2800" b="0" i="0" u="none" strike="noStrike" cap="none" spc="0" normalizeH="0" baseline="0" dirty="0">
-              <a:ln>
-                <a:noFill/>
-              </a:ln>
-              <a:solidFill>
-                <a:srgbClr val="000000"/>
-              </a:solidFill>
-              <a:effectLst/>
-              <a:uFillTx/>
-              <a:latin typeface="Calibri"/>
-              <a:ea typeface="Calibri"/>
-              <a:cs typeface="Calibri"/>
-              <a:sym typeface="Calibri"/>
-            </a:endParaRPr>
-          </a:p>
-          <a:p>
-            <a:pPr marL="0" marR="0" indent="0" algn="l" defTabSz="914400" rtl="0" fontAlgn="auto" latinLnBrk="1" hangingPunct="0">
-              <a:lnSpc>
-                <a:spcPct val="100000"/>
-              </a:lnSpc>
-              <a:spcBef>
-                <a:spcPts val="0"/>
-              </a:spcBef>
-              <a:spcAft>
-                <a:spcPts val="0"/>
-              </a:spcAft>
-              <a:buClrTx/>
-              <a:buSzTx/>
-              <a:buFontTx/>
-              <a:buNone/>
-              <a:tabLst/>
-            </a:pPr>
-            <a:r>
-              <a:rPr lang="en-US" sz="2800" dirty="0">
-                <a:solidFill>
-                  <a:srgbClr val="000000"/>
-                </a:solidFill>
-              </a:rPr>
-              <a:t>Blue X means tests failed</a:t>
-            </a:r>
-          </a:p>
-          <a:p>
-            <a:pPr marL="0" marR="0" indent="0" algn="l" defTabSz="914400" rtl="0" fontAlgn="auto" latinLnBrk="1" hangingPunct="0">
-              <a:lnSpc>
-                <a:spcPct val="100000"/>
-              </a:lnSpc>
-              <a:spcBef>
-                <a:spcPts val="0"/>
-              </a:spcBef>
-              <a:spcAft>
-                <a:spcPts val="0"/>
-              </a:spcAft>
-              <a:buClrTx/>
-              <a:buSzTx/>
-              <a:buFontTx/>
-              <a:buNone/>
-              <a:tabLst/>
-            </a:pPr>
-            <a:endParaRPr lang="en-US" sz="2800" dirty="0">
-              <a:solidFill>
-                <a:srgbClr val="000000"/>
-              </a:solidFill>
-            </a:endParaRPr>
-          </a:p>
-          <a:p>
-            <a:pPr marL="0" marR="0" indent="0" algn="l" defTabSz="914400" rtl="0" fontAlgn="auto" latinLnBrk="1" hangingPunct="0">
-              <a:lnSpc>
-                <a:spcPct val="100000"/>
-              </a:lnSpc>
-              <a:spcBef>
-                <a:spcPts val="0"/>
-              </a:spcBef>
-              <a:spcAft>
-                <a:spcPts val="0"/>
-              </a:spcAft>
-              <a:buClrTx/>
-              <a:buSzTx/>
-              <a:buFontTx/>
-              <a:buNone/>
-              <a:tabLst/>
-            </a:pPr>
-            <a:r>
-              <a:rPr kumimoji="0" lang="en-US" sz="2800" b="0" i="0" u="none" strike="noStrike" cap="none" spc="0" normalizeH="0" baseline="0" dirty="0">
-                <a:ln>
-                  <a:noFill/>
-                </a:ln>
-                <a:solidFill>
-                  <a:srgbClr val="000000"/>
-                </a:solidFill>
-                <a:effectLst/>
-                <a:uFillTx/>
-                <a:latin typeface="Calibri"/>
-                <a:ea typeface="Calibri"/>
-                <a:cs typeface="Calibri"/>
-                <a:sym typeface="Calibri"/>
-              </a:rPr>
-              <a:t>Red X means Exception (Error)</a:t>
-            </a:r>
-          </a:p>
-        </p:txBody>
-      </p:sp>
-      <p:pic>
-        <p:nvPicPr>
-          <p:cNvPr id="12" name="Picture 11">
-            <a:extLst>
-              <a:ext uri="{FF2B5EF4-FFF2-40B4-BE49-F238E27FC236}">
-                <a16:creationId xmlns:a16="http://schemas.microsoft.com/office/drawing/2014/main" id="{A054648A-BEAD-93F5-0A3E-38437CBBC6C7}"/>
-              </a:ext>
-            </a:extLst>
-          </p:cNvPr>
-          <p:cNvPicPr>
-            <a:picLocks noChangeAspect="1"/>
-          </p:cNvPicPr>
-          <p:nvPr/>
-        </p:nvPicPr>
-        <p:blipFill rotWithShape="1">
-          <a:blip r:embed="rId4"/>
-          <a:srcRect r="16162" b="16218"/>
-          <a:stretch/>
-        </p:blipFill>
-        <p:spPr>
-          <a:xfrm>
-            <a:off x="4051919" y="5976582"/>
-            <a:ext cx="551014" cy="508295"/>
+            <a:off x="2626417" y="2867651"/>
+            <a:ext cx="3891165" cy="1122697"/>
           </a:xfrm>
           <a:prstGeom prst="rect">
             <a:avLst/>
@@ -8330,10 +7106,10 @@
       </p:pic>
       <p:pic>
         <p:nvPicPr>
-          <p:cNvPr id="14" name="Picture 13">
+          <p:cNvPr id="11" name="Picture 10">
             <a:extLst>
               <a:ext uri="{FF2B5EF4-FFF2-40B4-BE49-F238E27FC236}">
-                <a16:creationId xmlns:a16="http://schemas.microsoft.com/office/drawing/2014/main" id="{5C36648F-BC9B-D335-4622-48E88C07018A}"/>
+                <a16:creationId xmlns:a16="http://schemas.microsoft.com/office/drawing/2014/main" id="{6A5E92CA-B568-FE19-59DA-319992A7EBC2}"/>
               </a:ext>
             </a:extLst>
           </p:cNvPr>
@@ -8343,105 +7119,15 @@
           <p:nvPr/>
         </p:nvPicPr>
         <p:blipFill>
-          <a:blip r:embed="rId5"/>
+          <a:blip r:embed="rId4"/>
           <a:stretch>
             <a:fillRect/>
           </a:stretch>
         </p:blipFill>
         <p:spPr>
           <a:xfrm>
-            <a:off x="4086264" y="5127614"/>
-            <a:ext cx="573873" cy="626045"/>
-          </a:xfrm>
-          <a:prstGeom prst="rect">
-            <a:avLst/>
-          </a:prstGeom>
-        </p:spPr>
-      </p:pic>
-      <p:pic>
-        <p:nvPicPr>
-          <p:cNvPr id="16" name="Picture 15">
-            <a:extLst>
-              <a:ext uri="{FF2B5EF4-FFF2-40B4-BE49-F238E27FC236}">
-                <a16:creationId xmlns:a16="http://schemas.microsoft.com/office/drawing/2014/main" id="{4FB8AAD5-F591-D9FB-54F0-0C5F7A123F74}"/>
-              </a:ext>
-            </a:extLst>
-          </p:cNvPr>
-          <p:cNvPicPr>
-            <a:picLocks noChangeAspect="1"/>
-          </p:cNvPicPr>
-          <p:nvPr/>
-        </p:nvPicPr>
-        <p:blipFill>
-          <a:blip r:embed="rId6"/>
-          <a:stretch>
-            <a:fillRect/>
-          </a:stretch>
-        </p:blipFill>
-        <p:spPr>
-          <a:xfrm>
-            <a:off x="4068779" y="4361223"/>
-            <a:ext cx="591725" cy="563548"/>
-          </a:xfrm>
-          <a:prstGeom prst="rect">
-            <a:avLst/>
-          </a:prstGeom>
-        </p:spPr>
-      </p:pic>
-      <p:pic>
-        <p:nvPicPr>
-          <p:cNvPr id="4" name="Picture 3">
-            <a:extLst>
-              <a:ext uri="{FF2B5EF4-FFF2-40B4-BE49-F238E27FC236}">
-                <a16:creationId xmlns:a16="http://schemas.microsoft.com/office/drawing/2014/main" id="{3580D359-E2F4-996F-1DB3-4D68CECCCE3D}"/>
-              </a:ext>
-            </a:extLst>
-          </p:cNvPr>
-          <p:cNvPicPr>
-            <a:picLocks noChangeAspect="1"/>
-          </p:cNvPicPr>
-          <p:nvPr/>
-        </p:nvPicPr>
-        <p:blipFill>
-          <a:blip r:embed="rId7"/>
-          <a:stretch>
-            <a:fillRect/>
-          </a:stretch>
-        </p:blipFill>
-        <p:spPr>
-          <a:xfrm>
-            <a:off x="1676400" y="3478665"/>
-            <a:ext cx="6108700" cy="482600"/>
-          </a:xfrm>
-          <a:prstGeom prst="rect">
-            <a:avLst/>
-          </a:prstGeom>
-        </p:spPr>
-      </p:pic>
-      <p:pic>
-        <p:nvPicPr>
-          <p:cNvPr id="9" name="Picture 8">
-            <a:extLst>
-              <a:ext uri="{FF2B5EF4-FFF2-40B4-BE49-F238E27FC236}">
-                <a16:creationId xmlns:a16="http://schemas.microsoft.com/office/drawing/2014/main" id="{7567CE7D-024A-2C2B-7861-4F9FB256A1A5}"/>
-              </a:ext>
-            </a:extLst>
-          </p:cNvPr>
-          <p:cNvPicPr>
-            <a:picLocks noChangeAspect="1"/>
-          </p:cNvPicPr>
-          <p:nvPr/>
-        </p:nvPicPr>
-        <p:blipFill>
-          <a:blip r:embed="rId8"/>
-          <a:stretch>
-            <a:fillRect/>
-          </a:stretch>
-        </p:blipFill>
-        <p:spPr>
-          <a:xfrm>
-            <a:off x="56333" y="4191000"/>
-            <a:ext cx="3672254" cy="2667000"/>
+            <a:off x="6115555" y="4550427"/>
+            <a:ext cx="2590800" cy="2176746"/>
           </a:xfrm>
           <a:prstGeom prst="rect">
             <a:avLst/>

</xml_diff>

<commit_message>
Remove JavaIntroQuiz mention from slides
We're not using daily quizzes in 202710
</commit_message>
<xml_diff>
--- a/ClassMaterials/JavaIntro/Slides/Part2-JavaIntro.pptx
+++ b/ClassMaterials/JavaIntro/Slides/Part2-JavaIntro.pptx
@@ -2801,7 +2801,7 @@
           </a:ln>
           <a:extLst>
             <a:ext uri="{C572A759-6A51-4108-AA02-DFA0A04FC94B}">
-              <ma14:wrappingTextBoxFlag xmlns:ma14="http://schemas.microsoft.com/office/mac/drawingml/2011/main" xmlns="" val="1"/>
+              <ma14:wrappingTextBoxFlag xmlns="" xmlns:ma14="http://schemas.microsoft.com/office/mac/drawingml/2011/main" val="1"/>
             </a:ext>
           </a:extLst>
         </p:spPr>
@@ -2844,7 +2844,7 @@
           </a:ln>
           <a:extLst>
             <a:ext uri="{C572A759-6A51-4108-AA02-DFA0A04FC94B}">
-              <ma14:wrappingTextBoxFlag xmlns:ma14="http://schemas.microsoft.com/office/mac/drawingml/2011/main" xmlns="" val="1"/>
+              <ma14:wrappingTextBoxFlag xmlns="" xmlns:ma14="http://schemas.microsoft.com/office/mac/drawingml/2011/main" val="1"/>
             </a:ext>
           </a:extLst>
         </p:spPr>
@@ -3339,20 +3339,6 @@
           <a:p>
             <a:r>
               <a:rPr lang="en-US" dirty="0"/>
-              <a:t>You have the </a:t>
-            </a:r>
-            <a:r>
-              <a:rPr lang="en-US" dirty="0" err="1"/>
-              <a:t>JavaIntroQuiz</a:t>
-            </a:r>
-            <a:r>
-              <a:rPr lang="en-US" dirty="0"/>
-              <a:t> to complete</a:t>
-            </a:r>
-          </a:p>
-          <a:p>
-            <a:r>
-              <a:rPr lang="en-US" dirty="0"/>
               <a:t>To see all assignment due dates, look at the calendar on Moodle, or </a:t>
             </a:r>
             <a:r>
@@ -3570,7 +3556,7 @@
           </a:ln>
           <a:extLst>
             <a:ext uri="{C572A759-6A51-4108-AA02-DFA0A04FC94B}">
-              <ma14:wrappingTextBoxFlag xmlns="" xmlns:ma14="http://schemas.microsoft.com/office/mac/drawingml/2011/main" val="1"/>
+              <ma14:wrappingTextBoxFlag xmlns:ma14="http://schemas.microsoft.com/office/mac/drawingml/2011/main" xmlns="" val="1"/>
             </a:ext>
           </a:extLst>
         </p:spPr>
@@ -4489,7 +4475,7 @@
           </a:prstGeom>
           <a:extLst>
             <a:ext uri="{C572A759-6A51-4108-AA02-DFA0A04FC94B}">
-              <ma14:wrappingTextBoxFlag xmlns="" xmlns:ma14="http://schemas.microsoft.com/office/mac/drawingml/2011/main" val="1"/>
+              <ma14:wrappingTextBoxFlag xmlns:ma14="http://schemas.microsoft.com/office/mac/drawingml/2011/main" xmlns="" val="1"/>
             </a:ext>
           </a:extLst>
         </p:spPr>
@@ -4970,7 +4956,7 @@
           </a:ln>
           <a:extLst>
             <a:ext uri="{C572A759-6A51-4108-AA02-DFA0A04FC94B}">
-              <ma14:wrappingTextBoxFlag xmlns="" xmlns:ma14="http://schemas.microsoft.com/office/mac/drawingml/2011/main" val="1"/>
+              <ma14:wrappingTextBoxFlag xmlns:ma14="http://schemas.microsoft.com/office/mac/drawingml/2011/main" xmlns="" val="1"/>
             </a:ext>
           </a:extLst>
         </p:spPr>
@@ -5474,7 +5460,7 @@
               <a:effectLst/>
               <a:extLst>
                 <a:ext uri="{C572A759-6A51-4108-AA02-DFA0A04FC94B}">
-                  <ma14:wrappingTextBoxFlag xmlns="" xmlns:ma14="http://schemas.microsoft.com/office/mac/drawingml/2011/main" val="1"/>
+                  <ma14:wrappingTextBoxFlag xmlns:ma14="http://schemas.microsoft.com/office/mac/drawingml/2011/main" xmlns="" val="1"/>
                 </a:ext>
               </a:extLst>
             </p:spPr>
@@ -5656,7 +5642,7 @@
               <a:effectLst/>
               <a:extLst>
                 <a:ext uri="{C572A759-6A51-4108-AA02-DFA0A04FC94B}">
-                  <ma14:wrappingTextBoxFlag xmlns="" xmlns:ma14="http://schemas.microsoft.com/office/mac/drawingml/2011/main" val="1"/>
+                  <ma14:wrappingTextBoxFlag xmlns:ma14="http://schemas.microsoft.com/office/mac/drawingml/2011/main" xmlns="" val="1"/>
                 </a:ext>
               </a:extLst>
             </p:spPr>
@@ -5829,7 +5815,7 @@
               <a:effectLst/>
               <a:extLst>
                 <a:ext uri="{C572A759-6A51-4108-AA02-DFA0A04FC94B}">
-                  <ma14:wrappingTextBoxFlag xmlns="" xmlns:ma14="http://schemas.microsoft.com/office/mac/drawingml/2011/main" val="1"/>
+                  <ma14:wrappingTextBoxFlag xmlns:ma14="http://schemas.microsoft.com/office/mac/drawingml/2011/main" xmlns="" val="1"/>
                 </a:ext>
               </a:extLst>
             </p:spPr>
@@ -6038,7 +6024,7 @@
               <a:effectLst/>
               <a:extLst>
                 <a:ext uri="{C572A759-6A51-4108-AA02-DFA0A04FC94B}">
-                  <ma14:wrappingTextBoxFlag xmlns="" xmlns:ma14="http://schemas.microsoft.com/office/mac/drawingml/2011/main" val="1"/>
+                  <ma14:wrappingTextBoxFlag xmlns:ma14="http://schemas.microsoft.com/office/mac/drawingml/2011/main" xmlns="" val="1"/>
                 </a:ext>
               </a:extLst>
             </p:spPr>
@@ -6234,7 +6220,7 @@
             <a:effectLst/>
             <a:extLst>
               <a:ext uri="{C572A759-6A51-4108-AA02-DFA0A04FC94B}">
-                <ma14:wrappingTextBoxFlag xmlns="" xmlns:ma14="http://schemas.microsoft.com/office/mac/drawingml/2011/main" val="1"/>
+                <ma14:wrappingTextBoxFlag xmlns:ma14="http://schemas.microsoft.com/office/mac/drawingml/2011/main" xmlns="" val="1"/>
               </a:ext>
             </a:extLst>
           </p:spPr>

</xml_diff>